<commit_message>
Regenerate viva PowerPoint for the frozen Decision Tree / Random Forest baseline.
Replace stale XGBoost slides with selection, temporal, and drift research evidence plus honest limitations.

Co-authored-by: Cursor <cursoragent@cursor.com>
</commit_message>
<xml_diff>
--- a/docs/Aegis_IDS_Viva_Presentation.pptx
+++ b/docs/Aegis_IDS_Viva_Presentation.pptx
@@ -17,6 +17,9 @@
     <p:sldId id="265" r:id="rId16"/>
     <p:sldId id="266" r:id="rId17"/>
     <p:sldId id="267" r:id="rId18"/>
+    <p:sldId id="268" r:id="rId19"/>
+    <p:sldId id="269" r:id="rId20"/>
+    <p:sldId id="270" r:id="rId21"/>
   </p:sldIdLst>
   <p:sldSz cx="12191695" cy="6858000" type="screen4x3"/>
   <p:notesSz cx="6858000" cy="9144000"/>
@@ -3150,8 +3153,8 @@
         </p:nvSpPr>
         <p:spPr>
           <a:xfrm>
-            <a:off x="731520" y="2011680"/>
-            <a:ext cx="10515600" cy="2743200"/>
+            <a:off x="731520" y="1645920"/>
+            <a:ext cx="10515600" cy="3657600"/>
           </a:xfrm>
           <a:prstGeom prst="rect">
             <a:avLst/>
@@ -3198,7 +3201,19 @@
                 <a:latin typeface="Calibri"/>
               </a:rPr>
               <a:t>
-Team members  ·  College  ·  Year</a:t>
+Frozen v1.1  ·  Decision Tree @ 0.85  ·  Random Forest (attack-only)</a:t>
+            </a:r>
+          </a:p>
+          <a:p>
+            <a:pPr algn="ctr"/>
+            <a:r>
+              <a:rPr sz="1400" b="0">
+                <a:solidFill>
+                  <a:srgbClr val="8FA6B5"/>
+                </a:solidFill>
+                <a:latin typeface="Calibri"/>
+              </a:rPr>
+              <a:t>Team members  ·  College  ·  Year</a:t>
             </a:r>
           </a:p>
         </p:txBody>
@@ -3293,7 +3308,7 @@
                 </a:solidFill>
                 <a:latin typeface="Calibri"/>
               </a:rPr>
-              <a:t>Simulation (RQ5) — LIVE DEMO</a:t>
+              <a:t>Drift &amp; residual errors</a:t>
             </a:r>
           </a:p>
         </p:txBody>
@@ -3307,7 +3322,7 @@
         <p:spPr>
           <a:xfrm>
             <a:off x="548640" y="1005840"/>
-            <a:ext cx="10972800" cy="548640"/>
+            <a:ext cx="10972800" cy="502920"/>
           </a:xfrm>
           <a:prstGeom prst="rect">
             <a:avLst/>
@@ -3321,13 +3336,13 @@
           <a:lstStyle/>
           <a:p>
             <a:r>
-              <a:rPr sz="1600" b="0">
+              <a:rPr sz="1500" b="0">
                 <a:solidFill>
                   <a:srgbClr val="8FA6B5"/>
                 </a:solidFill>
                 <a:latin typeface="Calibri"/>
               </a:rPr>
-              <a:t>Attack → Detect → Defend → Recover</a:t>
+              <a:t>IID monitoring + confusion structure</a:t>
             </a:r>
           </a:p>
         </p:txBody>
@@ -3340,8 +3355,8 @@
         </p:nvSpPr>
         <p:spPr>
           <a:xfrm>
-            <a:off x="640080" y="1737360"/>
-            <a:ext cx="10972800" cy="4754880"/>
+            <a:off x="548640" y="1691640"/>
+            <a:ext cx="6035040" cy="4754880"/>
           </a:xfrm>
           <a:prstGeom prst="rect">
             <a:avLst/>
@@ -3356,69 +3371,93 @@
           <a:p>
             <a:pPr>
               <a:spcAft>
-                <a:spcPts val="1000"/>
+                <a:spcPts val="800"/>
               </a:spcAft>
             </a:pPr>
             <a:r>
-              <a:rPr sz="2200" b="0">
+              <a:rPr sz="1700" b="0">
                 <a:solidFill>
                   <a:srgbClr val="E7F0F5"/>
                 </a:solidFill>
                 <a:latin typeface="Calibri"/>
               </a:rPr>
-              <a:t>•  Simplified topology: Attacker → Firewall → Router → Server / PCs + IDS</a:t>
+              <a:t>•  Train→test IID drift: 0 features with PSI ≥ 0.2 (expected same-corpus)</a:t>
             </a:r>
           </a:p>
           <a:p>
             <a:pPr>
               <a:spcAft>
-                <a:spcPts val="1000"/>
+                <a:spcPts val="800"/>
               </a:spcAft>
             </a:pPr>
             <a:r>
-              <a:rPr sz="2200" b="0">
+              <a:rPr sz="1700" b="0">
                 <a:solidFill>
                   <a:srgbClr val="E7F0F5"/>
                 </a:solidFill>
                 <a:latin typeface="Calibri"/>
               </a:rPr>
-              <a:t>•  Step through: normal → attack → impact → IDS alert → defense → recovery</a:t>
+              <a:t>•  Binary residuals: FP 1,377 · FN 255 (FPR 0.00329 / FNR 0.00300)</a:t>
             </a:r>
           </a:p>
           <a:p>
             <a:pPr>
               <a:spcAft>
-                <a:spcPts val="1000"/>
+                <a:spcPts val="800"/>
               </a:spcAft>
             </a:pPr>
             <a:r>
-              <a:rPr sz="2200" b="0">
+              <a:rPr sz="1700" b="0">
                 <a:solidFill>
                   <a:srgbClr val="E7F0F5"/>
                 </a:solidFill>
                 <a:latin typeface="Calibri"/>
               </a:rPr>
-              <a:t>•  Safety: controlled visualization only — no real cyberattacks</a:t>
+              <a:t>•  Multiclass: 18 errors / 85,139 attacks — PortScan / DoS / WebAttack</a:t>
             </a:r>
           </a:p>
           <a:p>
             <a:pPr>
               <a:spcAft>
-                <a:spcPts val="1000"/>
+                <a:spcPts val="800"/>
               </a:spcAft>
             </a:pPr>
             <a:r>
-              <a:rPr sz="2200" b="0">
+              <a:rPr sz="1700" b="0">
                 <a:solidFill>
                   <a:srgbClr val="E7F0F5"/>
                 </a:solidFill>
                 <a:latin typeface="Calibri"/>
               </a:rPr>
-              <a:t>•  Open UI → Simulation → New scenario → Next / Apply defense</a:t>
-            </a:r>
-          </a:p>
-        </p:txBody>
-      </p:sp>
+              <a:t>•  PSI≈0 ≠ live drift absence · external dataset = future work</a:t>
+            </a:r>
+          </a:p>
+        </p:txBody>
+      </p:sp>
+      <p:pic>
+        <p:nvPicPr>
+          <p:cNvPr id="6" name="Picture 5" descr="error_multiclass_top_confusions.png"/>
+          <p:cNvPicPr>
+            <a:picLocks noChangeAspect="1"/>
+          </p:cNvPicPr>
+          <p:nvPr/>
+        </p:nvPicPr>
+        <p:blipFill>
+          <a:blip r:embed="rId2"/>
+          <a:stretch>
+            <a:fillRect/>
+          </a:stretch>
+        </p:blipFill>
+        <p:spPr>
+          <a:xfrm>
+            <a:off x="6492240" y="1691640"/>
+            <a:ext cx="5212080" cy="2931795"/>
+          </a:xfrm>
+          <a:prstGeom prst="rect">
+            <a:avLst/>
+          </a:prstGeom>
+        </p:spPr>
+      </p:pic>
     </p:spTree>
   </p:cSld>
   <p:clrMapOvr>
@@ -3509,7 +3548,7 @@
                 </a:solidFill>
                 <a:latin typeface="Calibri"/>
               </a:rPr>
-              <a:t>Contribution &amp; limitations</a:t>
+              <a:t>Explainability (RQ2 / RQ3)</a:t>
             </a:r>
           </a:p>
         </p:txBody>
@@ -3522,8 +3561,8 @@
         </p:nvSpPr>
         <p:spPr>
           <a:xfrm>
-            <a:off x="640080" y="1737360"/>
-            <a:ext cx="10972800" cy="4754880"/>
+            <a:off x="548640" y="1691640"/>
+            <a:ext cx="5943600" cy="4754880"/>
           </a:xfrm>
           <a:prstGeom prst="rect">
             <a:avLst/>
@@ -3538,69 +3577,93 @@
           <a:p>
             <a:pPr>
               <a:spcAft>
-                <a:spcPts val="1000"/>
+                <a:spcPts val="800"/>
               </a:spcAft>
             </a:pPr>
             <a:r>
-              <a:rPr sz="2200" b="0">
+              <a:rPr sz="1800" b="0">
                 <a:solidFill>
                   <a:srgbClr val="E7F0F5"/>
                 </a:solidFill>
                 <a:latin typeface="Calibri"/>
               </a:rPr>
-              <a:t>•  Contribution: integrated decision-support + visualization for ML-IDS</a:t>
+              <a:t>•  SHAP: feature contributions for each prediction (primary)</a:t>
             </a:r>
           </a:p>
           <a:p>
             <a:pPr>
               <a:spcAft>
-                <a:spcPts val="1000"/>
+                <a:spcPts val="800"/>
               </a:spcAft>
             </a:pPr>
             <a:r>
-              <a:rPr sz="2200" b="0">
+              <a:rPr sz="1800" b="0">
                 <a:solidFill>
                   <a:srgbClr val="E7F0F5"/>
                 </a:solidFill>
                 <a:latin typeface="Calibri"/>
               </a:rPr>
-              <a:t>•  Limits: CICIDS2017 age / concept drift; pedagogical simulator</a:t>
+              <a:t>•  LIME: local surrogate explanation (secondary)</a:t>
             </a:r>
           </a:p>
           <a:p>
             <a:pPr>
               <a:spcAft>
-                <a:spcPts val="1000"/>
+                <a:spcPts val="800"/>
               </a:spcAft>
             </a:pPr>
             <a:r>
-              <a:rPr sz="2200" b="0">
+              <a:rPr sz="1800" b="0">
                 <a:solidFill>
                   <a:srgbClr val="E7F0F5"/>
                 </a:solidFill>
                 <a:latin typeface="Calibri"/>
               </a:rPr>
-              <a:t>•  Limits: rule-mapped recommendations (not learned policies)</a:t>
+              <a:t>•  Live demo: Detection → Why? → SHAP / LIME tabs</a:t>
             </a:r>
           </a:p>
           <a:p>
             <a:pPr>
               <a:spcAft>
-                <a:spcPts val="1000"/>
+                <a:spcPts val="800"/>
               </a:spcAft>
             </a:pPr>
             <a:r>
-              <a:rPr sz="2200" b="0">
+              <a:rPr sz="1800" b="0">
                 <a:solidFill>
                   <a:srgbClr val="E7F0F5"/>
                 </a:solidFill>
                 <a:latin typeface="Calibri"/>
               </a:rPr>
-              <a:t>•  Future: live PCAP→flows, PostgreSQL, analyst feedback loop</a:t>
-            </a:r>
-          </a:p>
-        </p:txBody>
-      </p:sp>
+              <a:t>•  Decision support — not treated as causal proof</a:t>
+            </a:r>
+          </a:p>
+        </p:txBody>
+      </p:sp>
+      <p:pic>
+        <p:nvPicPr>
+          <p:cNvPr id="5" name="Picture 4" descr="feature_importance.png"/>
+          <p:cNvPicPr>
+            <a:picLocks noChangeAspect="1"/>
+          </p:cNvPicPr>
+          <p:nvPr/>
+        </p:nvPicPr>
+        <p:blipFill>
+          <a:blip r:embed="rId2"/>
+          <a:stretch>
+            <a:fillRect/>
+          </a:stretch>
+        </p:blipFill>
+        <p:spPr>
+          <a:xfrm>
+            <a:off x="6583680" y="1737360"/>
+            <a:ext cx="5029200" cy="3143250"/>
+          </a:xfrm>
+          <a:prstGeom prst="rect">
+            <a:avLst/>
+          </a:prstGeom>
+        </p:spPr>
+      </p:pic>
     </p:spTree>
   </p:cSld>
   <p:clrMapOvr>
@@ -3670,8 +3733,8 @@
         </p:nvSpPr>
         <p:spPr>
           <a:xfrm>
-            <a:off x="731520" y="2377440"/>
-            <a:ext cx="10515600" cy="2286000"/>
+            <a:off x="548640" y="320040"/>
+            <a:ext cx="10972800" cy="914400"/>
           </a:xfrm>
           <a:prstGeom prst="rect">
             <a:avLst/>
@@ -3684,19 +3747,707 @@
           </a:bodyPr>
           <a:lstStyle/>
           <a:p>
+            <a:r>
+              <a:rPr sz="3200" b="1">
+                <a:solidFill>
+                  <a:srgbClr val="3EC7C2"/>
+                </a:solidFill>
+                <a:latin typeface="Calibri"/>
+              </a:rPr>
+              <a:t>Risk &amp; recommendations (RQ4)</a:t>
+            </a:r>
+          </a:p>
+        </p:txBody>
+      </p:sp>
+      <p:sp>
+        <p:nvSpPr>
+          <p:cNvPr id="4" name="TextBox 3"/>
+          <p:cNvSpPr txBox="1"/>
+          <p:nvPr/>
+        </p:nvSpPr>
+        <p:spPr>
+          <a:xfrm>
+            <a:off x="640080" y="1691640"/>
+            <a:ext cx="10972800" cy="4754880"/>
+          </a:xfrm>
+          <a:prstGeom prst="rect">
+            <a:avLst/>
+          </a:prstGeom>
+          <a:noFill/>
+        </p:spPr>
+        <p:txBody>
+          <a:bodyPr wrap="square">
+            <a:spAutoFit/>
+          </a:bodyPr>
+          <a:lstStyle/>
+          <a:p>
+            <a:pPr>
+              <a:spcAft>
+                <a:spcPts val="800"/>
+              </a:spcAft>
+            </a:pPr>
+            <a:r>
+              <a:rPr sz="2000" b="0">
+                <a:solidFill>
+                  <a:srgbClr val="E7F0F5"/>
+                </a:solidFill>
+                <a:latin typeface="Calibri"/>
+              </a:rPr>
+              <a:t>•  Risk weights: 50% attack base · 25% confidence · 15% intensity · 10% asset</a:t>
+            </a:r>
+          </a:p>
+          <a:p>
+            <a:pPr>
+              <a:spcAft>
+                <a:spcPts val="800"/>
+              </a:spcAft>
+            </a:pPr>
+            <a:r>
+              <a:rPr sz="2000" b="0">
+                <a:solidFill>
+                  <a:srgbClr val="E7F0F5"/>
+                </a:solidFill>
+                <a:latin typeface="Calibri"/>
+              </a:rPr>
+              <a:t>•  Severity bands: LOW / MEDIUM / HIGH / CRITICAL (project conventions)</a:t>
+            </a:r>
+          </a:p>
+          <a:p>
+            <a:pPr>
+              <a:spcAft>
+                <a:spcPts val="800"/>
+              </a:spcAft>
+            </a:pPr>
+            <a:r>
+              <a:rPr sz="2000" b="0">
+                <a:solidFill>
+                  <a:srgbClr val="E7F0F5"/>
+                </a:solidFill>
+                <a:latin typeface="Calibri"/>
+              </a:rPr>
+              <a:t>•  Playbooks: rate limiting, filtering, WAF, isolation, …</a:t>
+            </a:r>
+          </a:p>
+          <a:p>
+            <a:pPr>
+              <a:spcAft>
+                <a:spcPts val="800"/>
+              </a:spcAft>
+            </a:pPr>
+            <a:r>
+              <a:rPr sz="2000" b="0">
+                <a:solidFill>
+                  <a:srgbClr val="E7F0F5"/>
+                </a:solidFill>
+                <a:latin typeface="Calibri"/>
+              </a:rPr>
+              <a:t>•  Advisory only — platform does not auto-block real networks</a:t>
+            </a:r>
+          </a:p>
+        </p:txBody>
+      </p:sp>
+    </p:spTree>
+  </p:cSld>
+  <p:clrMapOvr>
+    <a:masterClrMapping/>
+  </p:clrMapOvr>
+</p:sld>
+</file>
+
+<file path=ppt/slides/slide13.xml><?xml version="1.0" encoding="utf-8"?>
+<p:sld xmlns:a="http://schemas.openxmlformats.org/drawingml/2006/main" xmlns:p="http://schemas.openxmlformats.org/presentationml/2006/main" xmlns:r="http://schemas.openxmlformats.org/officeDocument/2006/relationships">
+  <p:cSld>
+    <p:spTree>
+      <p:nvGrpSpPr>
+        <p:cNvPr id="1" name=""/>
+        <p:cNvGrpSpPr/>
+        <p:nvPr/>
+      </p:nvGrpSpPr>
+      <p:grpSpPr/>
+      <p:sp>
+        <p:nvSpPr>
+          <p:cNvPr id="2" name="Rectangle 1"/>
+          <p:cNvSpPr/>
+          <p:nvPr/>
+        </p:nvSpPr>
+        <p:spPr>
+          <a:xfrm>
+            <a:off x="0" y="0"/>
+            <a:ext cx="12191695" cy="6858000"/>
+          </a:xfrm>
+          <a:prstGeom prst="rect">
+            <a:avLst/>
+          </a:prstGeom>
+          <a:solidFill>
+            <a:srgbClr val="07111A"/>
+          </a:solidFill>
+          <a:ln>
+            <a:noFill/>
+          </a:ln>
+        </p:spPr>
+        <p:style>
+          <a:lnRef idx="1">
+            <a:schemeClr val="accent1"/>
+          </a:lnRef>
+          <a:fillRef idx="3">
+            <a:schemeClr val="accent1"/>
+          </a:fillRef>
+          <a:effectRef idx="2">
+            <a:schemeClr val="accent1"/>
+          </a:effectRef>
+          <a:fontRef idx="minor">
+            <a:schemeClr val="lt1"/>
+          </a:fontRef>
+        </p:style>
+        <p:txBody>
+          <a:bodyPr rtlCol="0" anchor="ctr"/>
+          <a:lstStyle/>
+          <a:p>
             <a:pPr algn="ctr"/>
-            <a:r>
-              <a:rPr sz="4800" b="1">
+          </a:p>
+        </p:txBody>
+      </p:sp>
+      <p:sp>
+        <p:nvSpPr>
+          <p:cNvPr id="3" name="TextBox 2"/>
+          <p:cNvSpPr txBox="1"/>
+          <p:nvPr/>
+        </p:nvSpPr>
+        <p:spPr>
+          <a:xfrm>
+            <a:off x="548640" y="320040"/>
+            <a:ext cx="10972800" cy="914400"/>
+          </a:xfrm>
+          <a:prstGeom prst="rect">
+            <a:avLst/>
+          </a:prstGeom>
+          <a:noFill/>
+        </p:spPr>
+        <p:txBody>
+          <a:bodyPr wrap="none">
+            <a:spAutoFit/>
+          </a:bodyPr>
+          <a:lstStyle/>
+          <a:p>
+            <a:r>
+              <a:rPr sz="3200" b="1">
                 <a:solidFill>
                   <a:srgbClr val="3EC7C2"/>
                 </a:solidFill>
                 <a:latin typeface="Calibri"/>
               </a:rPr>
-              <a:t>Questions?</a:t>
-            </a:r>
-          </a:p>
+              <a:t>Simulation (RQ5) — LIVE DEMO</a:t>
+            </a:r>
+          </a:p>
+        </p:txBody>
+      </p:sp>
+      <p:sp>
+        <p:nvSpPr>
+          <p:cNvPr id="4" name="TextBox 3"/>
+          <p:cNvSpPr txBox="1"/>
+          <p:nvPr/>
+        </p:nvSpPr>
+        <p:spPr>
+          <a:xfrm>
+            <a:off x="548640" y="1005840"/>
+            <a:ext cx="10972800" cy="502920"/>
+          </a:xfrm>
+          <a:prstGeom prst="rect">
+            <a:avLst/>
+          </a:prstGeom>
+          <a:noFill/>
+        </p:spPr>
+        <p:txBody>
+          <a:bodyPr wrap="none">
+            <a:spAutoFit/>
+          </a:bodyPr>
+          <a:lstStyle/>
+          <a:p>
+            <a:r>
+              <a:rPr sz="1500" b="0">
+                <a:solidFill>
+                  <a:srgbClr val="8FA6B5"/>
+                </a:solidFill>
+                <a:latin typeface="Calibri"/>
+              </a:rPr>
+              <a:t>Attack → Detect → Defend → Recover</a:t>
+            </a:r>
+          </a:p>
+        </p:txBody>
+      </p:sp>
+      <p:sp>
+        <p:nvSpPr>
+          <p:cNvPr id="5" name="TextBox 4"/>
+          <p:cNvSpPr txBox="1"/>
+          <p:nvPr/>
+        </p:nvSpPr>
+        <p:spPr>
+          <a:xfrm>
+            <a:off x="640080" y="1691640"/>
+            <a:ext cx="10972800" cy="4754880"/>
+          </a:xfrm>
+          <a:prstGeom prst="rect">
+            <a:avLst/>
+          </a:prstGeom>
+          <a:noFill/>
+        </p:spPr>
+        <p:txBody>
+          <a:bodyPr wrap="square">
+            <a:spAutoFit/>
+          </a:bodyPr>
+          <a:lstStyle/>
+          <a:p>
+            <a:pPr>
+              <a:spcAft>
+                <a:spcPts val="800"/>
+              </a:spcAft>
+            </a:pPr>
+            <a:r>
+              <a:rPr sz="2000" b="0">
+                <a:solidFill>
+                  <a:srgbClr val="E7F0F5"/>
+                </a:solidFill>
+                <a:latin typeface="Calibri"/>
+              </a:rPr>
+              <a:t>•  Topology: Attacker → Firewall → Router → Server / PCs + IDS</a:t>
+            </a:r>
+          </a:p>
+          <a:p>
+            <a:pPr>
+              <a:spcAft>
+                <a:spcPts val="800"/>
+              </a:spcAft>
+            </a:pPr>
+            <a:r>
+              <a:rPr sz="2000" b="0">
+                <a:solidFill>
+                  <a:srgbClr val="E7F0F5"/>
+                </a:solidFill>
+                <a:latin typeface="Calibri"/>
+              </a:rPr>
+              <a:t>•  Step: normal → attack → impact → IDS alert → defense → recovery</a:t>
+            </a:r>
+          </a:p>
+          <a:p>
+            <a:pPr>
+              <a:spcAft>
+                <a:spcPts val="800"/>
+              </a:spcAft>
+            </a:pPr>
+            <a:r>
+              <a:rPr sz="2000" b="0">
+                <a:solidFill>
+                  <a:srgbClr val="E7F0F5"/>
+                </a:solidFill>
+                <a:latin typeface="Calibri"/>
+              </a:rPr>
+              <a:t>•  Defense effectiveness values are simulation assumptions</a:t>
+            </a:r>
+          </a:p>
+          <a:p>
+            <a:pPr>
+              <a:spcAft>
+                <a:spcPts val="800"/>
+              </a:spcAft>
+            </a:pPr>
+            <a:r>
+              <a:rPr sz="2000" b="0">
+                <a:solidFill>
+                  <a:srgbClr val="E7F0F5"/>
+                </a:solidFill>
+                <a:latin typeface="Calibri"/>
+              </a:rPr>
+              <a:t>•  Safety: controlled visualization only — no real cyberattacks</a:t>
+            </a:r>
+          </a:p>
+        </p:txBody>
+      </p:sp>
+    </p:spTree>
+  </p:cSld>
+  <p:clrMapOvr>
+    <a:masterClrMapping/>
+  </p:clrMapOvr>
+</p:sld>
+</file>
+
+<file path=ppt/slides/slide14.xml><?xml version="1.0" encoding="utf-8"?>
+<p:sld xmlns:a="http://schemas.openxmlformats.org/drawingml/2006/main" xmlns:p="http://schemas.openxmlformats.org/presentationml/2006/main" xmlns:r="http://schemas.openxmlformats.org/officeDocument/2006/relationships">
+  <p:cSld>
+    <p:spTree>
+      <p:nvGrpSpPr>
+        <p:cNvPr id="1" name=""/>
+        <p:cNvGrpSpPr/>
+        <p:nvPr/>
+      </p:nvGrpSpPr>
+      <p:grpSpPr/>
+      <p:sp>
+        <p:nvSpPr>
+          <p:cNvPr id="2" name="Rectangle 1"/>
+          <p:cNvSpPr/>
+          <p:nvPr/>
+        </p:nvSpPr>
+        <p:spPr>
+          <a:xfrm>
+            <a:off x="0" y="0"/>
+            <a:ext cx="12191695" cy="6858000"/>
+          </a:xfrm>
+          <a:prstGeom prst="rect">
+            <a:avLst/>
+          </a:prstGeom>
+          <a:solidFill>
+            <a:srgbClr val="07111A"/>
+          </a:solidFill>
+          <a:ln>
+            <a:noFill/>
+          </a:ln>
+        </p:spPr>
+        <p:style>
+          <a:lnRef idx="1">
+            <a:schemeClr val="accent1"/>
+          </a:lnRef>
+          <a:fillRef idx="3">
+            <a:schemeClr val="accent1"/>
+          </a:fillRef>
+          <a:effectRef idx="2">
+            <a:schemeClr val="accent1"/>
+          </a:effectRef>
+          <a:fontRef idx="minor">
+            <a:schemeClr val="lt1"/>
+          </a:fontRef>
+        </p:style>
+        <p:txBody>
+          <a:bodyPr rtlCol="0" anchor="ctr"/>
+          <a:lstStyle/>
           <a:p>
             <a:pPr algn="ctr"/>
+          </a:p>
+        </p:txBody>
+      </p:sp>
+      <p:sp>
+        <p:nvSpPr>
+          <p:cNvPr id="3" name="TextBox 2"/>
+          <p:cNvSpPr txBox="1"/>
+          <p:nvPr/>
+        </p:nvSpPr>
+        <p:spPr>
+          <a:xfrm>
+            <a:off x="548640" y="320040"/>
+            <a:ext cx="10972800" cy="914400"/>
+          </a:xfrm>
+          <a:prstGeom prst="rect">
+            <a:avLst/>
+          </a:prstGeom>
+          <a:noFill/>
+        </p:spPr>
+        <p:txBody>
+          <a:bodyPr wrap="none">
+            <a:spAutoFit/>
+          </a:bodyPr>
+          <a:lstStyle/>
+          <a:p>
+            <a:r>
+              <a:rPr sz="3200" b="1">
+                <a:solidFill>
+                  <a:srgbClr val="3EC7C2"/>
+                </a:solidFill>
+                <a:latin typeface="Calibri"/>
+              </a:rPr>
+              <a:t>Limitations &amp; threats to validity</a:t>
+            </a:r>
+          </a:p>
+        </p:txBody>
+      </p:sp>
+      <p:sp>
+        <p:nvSpPr>
+          <p:cNvPr id="4" name="TextBox 3"/>
+          <p:cNvSpPr txBox="1"/>
+          <p:nvPr/>
+        </p:nvSpPr>
+        <p:spPr>
+          <a:xfrm>
+            <a:off x="640080" y="1691640"/>
+            <a:ext cx="10972800" cy="4754880"/>
+          </a:xfrm>
+          <a:prstGeom prst="rect">
+            <a:avLst/>
+          </a:prstGeom>
+          <a:noFill/>
+        </p:spPr>
+        <p:txBody>
+          <a:bodyPr wrap="square">
+            <a:spAutoFit/>
+          </a:bodyPr>
+          <a:lstStyle/>
+          <a:p>
+            <a:pPr>
+              <a:spcAft>
+                <a:spcPts val="800"/>
+              </a:spcAft>
+            </a:pPr>
+            <a:r>
+              <a:rPr sz="1800" b="0">
+                <a:solidFill>
+                  <a:srgbClr val="E7F0F5"/>
+                </a:solidFill>
+                <a:latin typeface="Calibri"/>
+              </a:rPr>
+              <a:t>•  CICIDS2017 age / scenario structure ≠ continuous enterprise traffic</a:t>
+            </a:r>
+          </a:p>
+          <a:p>
+            <a:pPr>
+              <a:spcAft>
+                <a:spcPts val="800"/>
+              </a:spcAft>
+            </a:pPr>
+            <a:r>
+              <a:rPr sz="1800" b="0">
+                <a:solidFill>
+                  <a:srgbClr val="E7F0F5"/>
+                </a:solidFill>
+                <a:latin typeface="Calibri"/>
+              </a:rPr>
+              <a:t>•  Temporal slices are capped samples; multiclass temporal coverage incomplete</a:t>
+            </a:r>
+          </a:p>
+          <a:p>
+            <a:pPr>
+              <a:spcAft>
+                <a:spcPts val="800"/>
+              </a:spcAft>
+            </a:pPr>
+            <a:r>
+              <a:rPr sz="1800" b="0">
+                <a:solidFill>
+                  <a:srgbClr val="E7F0F5"/>
+                </a:solidFill>
+                <a:latin typeface="Calibri"/>
+              </a:rPr>
+              <a:t>•  IID drift check ≠ temporal / live / cross-dataset drift</a:t>
+            </a:r>
+          </a:p>
+          <a:p>
+            <a:pPr>
+              <a:spcAft>
+                <a:spcPts val="800"/>
+              </a:spcAft>
+            </a:pPr>
+            <a:r>
+              <a:rPr sz="1800" b="0">
+                <a:solidFill>
+                  <a:srgbClr val="E7F0F5"/>
+                </a:solidFill>
+                <a:latin typeface="Calibri"/>
+              </a:rPr>
+              <a:t>•  External-dataset validation not performed — stated as future work</a:t>
+            </a:r>
+          </a:p>
+          <a:p>
+            <a:pPr>
+              <a:spcAft>
+                <a:spcPts val="800"/>
+              </a:spcAft>
+            </a:pPr>
+            <a:r>
+              <a:rPr sz="1800" b="0">
+                <a:solidFill>
+                  <a:srgbClr val="E7F0F5"/>
+                </a:solidFill>
+                <a:latin typeface="Calibri"/>
+              </a:rPr>
+              <a:t>•  Not a claim of production IDS readiness</a:t>
+            </a:r>
+          </a:p>
+        </p:txBody>
+      </p:sp>
+    </p:spTree>
+  </p:cSld>
+  <p:clrMapOvr>
+    <a:masterClrMapping/>
+  </p:clrMapOvr>
+</p:sld>
+</file>
+
+<file path=ppt/slides/slide15.xml><?xml version="1.0" encoding="utf-8"?>
+<p:sld xmlns:a="http://schemas.openxmlformats.org/drawingml/2006/main" xmlns:p="http://schemas.openxmlformats.org/presentationml/2006/main" xmlns:r="http://schemas.openxmlformats.org/officeDocument/2006/relationships">
+  <p:cSld>
+    <p:spTree>
+      <p:nvGrpSpPr>
+        <p:cNvPr id="1" name=""/>
+        <p:cNvGrpSpPr/>
+        <p:nvPr/>
+      </p:nvGrpSpPr>
+      <p:grpSpPr/>
+      <p:sp>
+        <p:nvSpPr>
+          <p:cNvPr id="2" name="Rectangle 1"/>
+          <p:cNvSpPr/>
+          <p:nvPr/>
+        </p:nvSpPr>
+        <p:spPr>
+          <a:xfrm>
+            <a:off x="0" y="0"/>
+            <a:ext cx="12191695" cy="6858000"/>
+          </a:xfrm>
+          <a:prstGeom prst="rect">
+            <a:avLst/>
+          </a:prstGeom>
+          <a:solidFill>
+            <a:srgbClr val="07111A"/>
+          </a:solidFill>
+          <a:ln>
+            <a:noFill/>
+          </a:ln>
+        </p:spPr>
+        <p:style>
+          <a:lnRef idx="1">
+            <a:schemeClr val="accent1"/>
+          </a:lnRef>
+          <a:fillRef idx="3">
+            <a:schemeClr val="accent1"/>
+          </a:fillRef>
+          <a:effectRef idx="2">
+            <a:schemeClr val="accent1"/>
+          </a:effectRef>
+          <a:fontRef idx="minor">
+            <a:schemeClr val="lt1"/>
+          </a:fontRef>
+        </p:style>
+        <p:txBody>
+          <a:bodyPr rtlCol="0" anchor="ctr"/>
+          <a:lstStyle/>
+          <a:p>
+            <a:pPr algn="ctr"/>
+          </a:p>
+        </p:txBody>
+      </p:sp>
+      <p:sp>
+        <p:nvSpPr>
+          <p:cNvPr id="3" name="TextBox 2"/>
+          <p:cNvSpPr txBox="1"/>
+          <p:nvPr/>
+        </p:nvSpPr>
+        <p:spPr>
+          <a:xfrm>
+            <a:off x="548640" y="320040"/>
+            <a:ext cx="10972800" cy="914400"/>
+          </a:xfrm>
+          <a:prstGeom prst="rect">
+            <a:avLst/>
+          </a:prstGeom>
+          <a:noFill/>
+        </p:spPr>
+        <p:txBody>
+          <a:bodyPr wrap="none">
+            <a:spAutoFit/>
+          </a:bodyPr>
+          <a:lstStyle/>
+          <a:p>
+            <a:r>
+              <a:rPr sz="3200" b="1">
+                <a:solidFill>
+                  <a:srgbClr val="3EC7C2"/>
+                </a:solidFill>
+                <a:latin typeface="Calibri"/>
+              </a:rPr>
+              <a:t>Contribution</a:t>
+            </a:r>
+          </a:p>
+        </p:txBody>
+      </p:sp>
+      <p:sp>
+        <p:nvSpPr>
+          <p:cNvPr id="4" name="TextBox 3"/>
+          <p:cNvSpPr txBox="1"/>
+          <p:nvPr/>
+        </p:nvSpPr>
+        <p:spPr>
+          <a:xfrm>
+            <a:off x="640080" y="1645920"/>
+            <a:ext cx="10972800" cy="4754880"/>
+          </a:xfrm>
+          <a:prstGeom prst="rect">
+            <a:avLst/>
+          </a:prstGeom>
+          <a:noFill/>
+        </p:spPr>
+        <p:txBody>
+          <a:bodyPr wrap="square">
+            <a:spAutoFit/>
+          </a:bodyPr>
+          <a:lstStyle/>
+          <a:p>
+            <a:pPr>
+              <a:spcAft>
+                <a:spcPts val="800"/>
+              </a:spcAft>
+            </a:pPr>
+            <a:r>
+              <a:rPr sz="2000" b="0">
+                <a:solidFill>
+                  <a:srgbClr val="E7F0F5"/>
+                </a:solidFill>
+                <a:latin typeface="Calibri"/>
+              </a:rPr>
+              <a:t>•  Integrated ML-IDS decision-support + visualization platform</a:t>
+            </a:r>
+          </a:p>
+          <a:p>
+            <a:pPr>
+              <a:spcAft>
+                <a:spcPts val="800"/>
+              </a:spcAft>
+            </a:pPr>
+            <a:r>
+              <a:rPr sz="2000" b="0">
+                <a:solidFill>
+                  <a:srgbClr val="E7F0F5"/>
+                </a:solidFill>
+                <a:latin typeface="Calibri"/>
+              </a:rPr>
+              <a:t>•  Honest evaluation: IID · temporal · drift · residual errors · model selection</a:t>
+            </a:r>
+          </a:p>
+          <a:p>
+            <a:pPr>
+              <a:spcAft>
+                <a:spcPts val="800"/>
+              </a:spcAft>
+            </a:pPr>
+            <a:r>
+              <a:rPr sz="2000" b="0">
+                <a:solidFill>
+                  <a:srgbClr val="E7F0F5"/>
+                </a:solidFill>
+                <a:latin typeface="Calibri"/>
+              </a:rPr>
+              <a:t>•  Research baseline frozen; Stage-2 productionization is a separate track</a:t>
+            </a:r>
+          </a:p>
+        </p:txBody>
+      </p:sp>
+      <p:sp>
+        <p:nvSpPr>
+          <p:cNvPr id="5" name="TextBox 4"/>
+          <p:cNvSpPr txBox="1"/>
+          <p:nvPr/>
+        </p:nvSpPr>
+        <p:spPr>
+          <a:xfrm>
+            <a:off x="640080" y="4754880"/>
+            <a:ext cx="10972800" cy="1371600"/>
+          </a:xfrm>
+          <a:prstGeom prst="rect">
+            <a:avLst/>
+          </a:prstGeom>
+          <a:noFill/>
+        </p:spPr>
+        <p:txBody>
+          <a:bodyPr wrap="none">
+            <a:spAutoFit/>
+          </a:bodyPr>
+          <a:lstStyle/>
+          <a:p>
             <a:r>
               <a:rPr sz="1600" b="0">
                 <a:solidFill>
@@ -3704,7 +4455,7 @@
                 </a:solidFill>
                 <a:latin typeface="Calibri"/>
               </a:rPr>
-              <a:t>Demo script: docs/DEMO.md   ·   Report: docs/Aegis_IDS_Project_Report.docx</a:t>
+              <a:t>Questions?   ·   docs/DEMO.md   ·   docs/VIVA_QA.md   ·   docs/Aegis_IDS_Project_Report.docx</a:t>
             </a:r>
           </a:p>
         </p:txBody>
@@ -3813,7 +4564,7 @@
         <p:spPr>
           <a:xfrm>
             <a:off x="548640" y="1005840"/>
-            <a:ext cx="10972800" cy="548640"/>
+            <a:ext cx="10972800" cy="502920"/>
           </a:xfrm>
           <a:prstGeom prst="rect">
             <a:avLst/>
@@ -3827,7 +4578,7 @@
           <a:lstStyle/>
           <a:p>
             <a:r>
-              <a:rPr sz="1600" b="0">
+              <a:rPr sz="1500" b="0">
                 <a:solidFill>
                   <a:srgbClr val="8FA6B5"/>
                 </a:solidFill>
@@ -3846,7 +4597,7 @@
         </p:nvSpPr>
         <p:spPr>
           <a:xfrm>
-            <a:off x="640080" y="1737360"/>
+            <a:off x="640080" y="1691640"/>
             <a:ext cx="10972800" cy="4754880"/>
           </a:xfrm>
           <a:prstGeom prst="rect">
@@ -3862,11 +4613,11 @@
           <a:p>
             <a:pPr>
               <a:spcAft>
-                <a:spcPts val="1000"/>
+                <a:spcPts val="800"/>
               </a:spcAft>
             </a:pPr>
             <a:r>
-              <a:rPr sz="2200" b="0">
+              <a:rPr sz="2000" b="0">
                 <a:solidFill>
                   <a:srgbClr val="E7F0F5"/>
                 </a:solidFill>
@@ -3878,11 +4629,11 @@
           <a:p>
             <a:pPr>
               <a:spcAft>
-                <a:spcPts val="1000"/>
+                <a:spcPts val="800"/>
               </a:spcAft>
             </a:pPr>
             <a:r>
-              <a:rPr sz="2200" b="0">
+              <a:rPr sz="2000" b="0">
                 <a:solidFill>
                   <a:srgbClr val="E7F0F5"/>
                 </a:solidFill>
@@ -3894,27 +4645,27 @@
           <a:p>
             <a:pPr>
               <a:spcAft>
-                <a:spcPts val="1000"/>
+                <a:spcPts val="800"/>
               </a:spcAft>
             </a:pPr>
             <a:r>
-              <a:rPr sz="2200" b="0">
+              <a:rPr sz="2000" b="0">
                 <a:solidFill>
                   <a:srgbClr val="E7F0F5"/>
                 </a:solidFill>
                 <a:latin typeface="Calibri"/>
               </a:rPr>
-              <a:t>•  Students/evaluators also need a visual attack → defense story</a:t>
+              <a:t>•  Evaluators also need a visual attack → defense story</a:t>
             </a:r>
           </a:p>
           <a:p>
             <a:pPr>
               <a:spcAft>
-                <a:spcPts val="1000"/>
+                <a:spcPts val="800"/>
               </a:spcAft>
             </a:pPr>
             <a:r>
-              <a:rPr sz="2200" b="0">
+              <a:rPr sz="2000" b="0">
                 <a:solidFill>
                   <a:srgbClr val="E7F0F5"/>
                 </a:solidFill>
@@ -4028,7 +4779,7 @@
         </p:nvSpPr>
         <p:spPr>
           <a:xfrm>
-            <a:off x="640080" y="1737360"/>
+            <a:off x="640080" y="1691640"/>
             <a:ext cx="10972800" cy="4754880"/>
           </a:xfrm>
           <a:prstGeom prst="rect">
@@ -4044,11 +4795,11 @@
           <a:p>
             <a:pPr>
               <a:spcAft>
-                <a:spcPts val="1000"/>
+                <a:spcPts val="800"/>
               </a:spcAft>
             </a:pPr>
             <a:r>
-              <a:rPr sz="2400" b="0">
+              <a:rPr sz="2200" b="0">
                 <a:solidFill>
                   <a:srgbClr val="E7F0F5"/>
                 </a:solidFill>
@@ -4060,33 +4811,49 @@
           <a:p>
             <a:pPr>
               <a:spcAft>
-                <a:spcPts val="1000"/>
+                <a:spcPts val="800"/>
               </a:spcAft>
             </a:pPr>
             <a:r>
-              <a:rPr sz="2400" b="0">
+              <a:rPr sz="2200" b="0">
                 <a:solidFill>
                   <a:srgbClr val="E7F0F5"/>
                 </a:solidFill>
                 <a:latin typeface="Calibri"/>
               </a:rPr>
-              <a:t>•  Platform name: Aegis IDS</a:t>
+              <a:t>•  Platform: Aegis IDS (prototype / decision-support)</a:t>
             </a:r>
           </a:p>
           <a:p>
             <a:pPr>
               <a:spcAft>
-                <a:spcPts val="1000"/>
+                <a:spcPts val="800"/>
               </a:spcAft>
             </a:pPr>
             <a:r>
-              <a:rPr sz="2400" b="0">
+              <a:rPr sz="2200" b="0">
                 <a:solidFill>
                   <a:srgbClr val="E7F0F5"/>
                 </a:solidFill>
                 <a:latin typeface="Calibri"/>
               </a:rPr>
-              <a:t>•  Contribution: integration framework — not a claim of a new IDS algorithm</a:t>
+              <a:t>•  Contribution: integration + honest evaluation — not a new IDS algorithm claim</a:t>
+            </a:r>
+          </a:p>
+          <a:p>
+            <a:pPr>
+              <a:spcAft>
+                <a:spcPts val="800"/>
+              </a:spcAft>
+            </a:pPr>
+            <a:r>
+              <a:rPr sz="2200" b="0">
+                <a:solidFill>
+                  <a:srgbClr val="E7F0F5"/>
+                </a:solidFill>
+                <a:latin typeface="Calibri"/>
+              </a:rPr>
+              <a:t>•  Safety: no live capture claim · no automatic network blocking</a:t>
             </a:r>
           </a:p>
         </p:txBody>
@@ -4194,7 +4961,7 @@
         </p:nvSpPr>
         <p:spPr>
           <a:xfrm>
-            <a:off x="640080" y="1737360"/>
+            <a:off x="640080" y="1691640"/>
             <a:ext cx="10972800" cy="4754880"/>
           </a:xfrm>
           <a:prstGeom prst="rect">
@@ -4210,11 +4977,11 @@
           <a:p>
             <a:pPr>
               <a:spcAft>
-                <a:spcPts val="1000"/>
+                <a:spcPts val="800"/>
               </a:spcAft>
             </a:pPr>
             <a:r>
-              <a:rPr sz="2200" b="0">
+              <a:rPr sz="2000" b="0">
                 <a:solidFill>
                   <a:srgbClr val="E7F0F5"/>
                 </a:solidFill>
@@ -4226,43 +4993,43 @@
           <a:p>
             <a:pPr>
               <a:spcAft>
-                <a:spcPts val="1000"/>
+                <a:spcPts val="800"/>
               </a:spcAft>
             </a:pPr>
             <a:r>
-              <a:rPr sz="2200" b="0">
+              <a:rPr sz="2000" b="0">
                 <a:solidFill>
                   <a:srgbClr val="E7F0F5"/>
                 </a:solidFill>
                 <a:latin typeface="Calibri"/>
               </a:rPr>
-              <a:t>•  Data: CICIDS2017 flows · trained models · SQLite incidents</a:t>
+              <a:t>•  Data: CICIDS2017 MachineLearningCVE · trained models · SQLite incidents</a:t>
             </a:r>
           </a:p>
           <a:p>
             <a:pPr>
               <a:spcAft>
-                <a:spcPts val="1000"/>
+                <a:spcPts val="800"/>
               </a:spcAft>
             </a:pPr>
             <a:r>
-              <a:rPr sz="2200" b="0">
+              <a:rPr sz="2000" b="0">
                 <a:solidFill>
                   <a:srgbClr val="E7F0F5"/>
                 </a:solidFill>
                 <a:latin typeface="Calibri"/>
               </a:rPr>
-              <a:t>•  Two-stage ML: binary (benign vs attack) then attack-family multiclass</a:t>
+              <a:t>•  Two-stage ML: binary then attack-family multiclass (no BENIGN in Stage-2)</a:t>
             </a:r>
           </a:p>
           <a:p>
             <a:pPr>
               <a:spcAft>
-                <a:spcPts val="1000"/>
+                <a:spcPts val="800"/>
               </a:spcAft>
             </a:pPr>
             <a:r>
-              <a:rPr sz="2200" b="0">
+              <a:rPr sz="2000" b="0">
                 <a:solidFill>
                   <a:srgbClr val="E7F0F5"/>
                 </a:solidFill>
@@ -4377,7 +5144,7 @@
         <p:spPr>
           <a:xfrm>
             <a:off x="548640" y="1005840"/>
-            <a:ext cx="10972800" cy="548640"/>
+            <a:ext cx="10972800" cy="502920"/>
           </a:xfrm>
           <a:prstGeom prst="rect">
             <a:avLst/>
@@ -4391,7 +5158,7 @@
           <a:lstStyle/>
           <a:p>
             <a:r>
-              <a:rPr sz="1600" b="0">
+              <a:rPr sz="1500" b="0">
                 <a:solidFill>
                   <a:srgbClr val="8FA6B5"/>
                 </a:solidFill>
@@ -4410,7 +5177,7 @@
         </p:nvSpPr>
         <p:spPr>
           <a:xfrm>
-            <a:off x="640080" y="1737360"/>
+            <a:off x="640080" y="1691640"/>
             <a:ext cx="10972800" cy="4754880"/>
           </a:xfrm>
           <a:prstGeom prst="rect">
@@ -4426,11 +5193,11 @@
           <a:p>
             <a:pPr>
               <a:spcAft>
-                <a:spcPts val="1000"/>
+                <a:spcPts val="800"/>
               </a:spcAft>
             </a:pPr>
             <a:r>
-              <a:rPr sz="2200" b="0">
+              <a:rPr sz="2000" b="0">
                 <a:solidFill>
                   <a:srgbClr val="E7F0F5"/>
                 </a:solidFill>
@@ -4442,11 +5209,11 @@
           <a:p>
             <a:pPr>
               <a:spcAft>
-                <a:spcPts val="1000"/>
+                <a:spcPts val="800"/>
               </a:spcAft>
             </a:pPr>
             <a:r>
-              <a:rPr sz="2200" b="0">
+              <a:rPr sz="2000" b="0">
                 <a:solidFill>
                   <a:srgbClr val="E7F0F5"/>
                 </a:solidFill>
@@ -4458,33 +5225,33 @@
           <a:p>
             <a:pPr>
               <a:spcAft>
-                <a:spcPts val="1000"/>
+                <a:spcPts val="800"/>
               </a:spcAft>
             </a:pPr>
             <a:r>
-              <a:rPr sz="2200" b="0">
+              <a:rPr sz="2000" b="0">
                 <a:solidFill>
                   <a:srgbClr val="E7F0F5"/>
                 </a:solidFill>
                 <a:latin typeface="Calibri"/>
               </a:rPr>
-              <a:t>•  Scaler + SelectKBest fit on train only (no leakage)</a:t>
+              <a:t>•  StandardScaler + SelectKBest(f_classif, k=40) fit on train only</a:t>
             </a:r>
           </a:p>
           <a:p>
             <a:pPr>
               <a:spcAft>
-                <a:spcPts val="1000"/>
+                <a:spcPts val="800"/>
               </a:spcAft>
             </a:pPr>
             <a:r>
-              <a:rPr sz="2200" b="0">
+              <a:rPr sz="2000" b="0">
                 <a:solidFill>
                   <a:srgbClr val="E7F0F5"/>
                 </a:solidFill>
                 <a:latin typeface="Calibri"/>
               </a:rPr>
-              <a:t>•  Families: BENIGN, DoS, DDoS, PortScan, BruteForce, WebAttack, Bot</a:t>
+              <a:t>•  Attack families: Bot · BruteForce · DDoS · DoS · PortScan · WebAttack</a:t>
             </a:r>
           </a:p>
         </p:txBody>
@@ -4593,7 +5360,7 @@
         <p:spPr>
           <a:xfrm>
             <a:off x="548640" y="1005840"/>
-            <a:ext cx="10972800" cy="548640"/>
+            <a:ext cx="10972800" cy="502920"/>
           </a:xfrm>
           <a:prstGeom prst="rect">
             <a:avLst/>
@@ -4607,13 +5374,13 @@
           <a:lstStyle/>
           <a:p>
             <a:r>
-              <a:rPr sz="1600" b="0">
+              <a:rPr sz="1500" b="0">
                 <a:solidFill>
                   <a:srgbClr val="8FA6B5"/>
                 </a:solidFill>
                 <a:latin typeface="Calibri"/>
               </a:rPr>
-              <a:t>Best model: XGBoost</a:t>
+              <a:t>Binary: Decision Tree @ 0.85  ·  Multiclass: Random Forest</a:t>
             </a:r>
           </a:p>
         </p:txBody>
@@ -4626,7 +5393,7 @@
         </p:nvSpPr>
         <p:spPr>
           <a:xfrm>
-            <a:off x="640080" y="1737360"/>
+            <a:off x="640080" y="1691640"/>
             <a:ext cx="10972800" cy="4754880"/>
           </a:xfrm>
           <a:prstGeom prst="rect">
@@ -4642,65 +5409,65 @@
           <a:p>
             <a:pPr>
               <a:spcAft>
-                <a:spcPts val="1000"/>
+                <a:spcPts val="800"/>
               </a:spcAft>
             </a:pPr>
             <a:r>
-              <a:rPr sz="2200" b="0">
+              <a:rPr sz="1900" b="0">
                 <a:solidFill>
                   <a:srgbClr val="E7F0F5"/>
                 </a:solidFill>
                 <a:latin typeface="Calibri"/>
               </a:rPr>
-              <a:t>•  Binary test: F1 ≈ 0.993 · Recall ≈ 0.990 · ROC-AUC ≈ 0.9999</a:t>
+              <a:t>•  Binary test: F1 0.99048 · Recall 0.997 · ROC-AUC 0.99916 · FPR 0.00329</a:t>
             </a:r>
           </a:p>
           <a:p>
             <a:pPr>
               <a:spcAft>
-                <a:spcPts val="1000"/>
+                <a:spcPts val="800"/>
               </a:spcAft>
             </a:pPr>
             <a:r>
-              <a:rPr sz="2200" b="0">
+              <a:rPr sz="1900" b="0">
                 <a:solidFill>
                   <a:srgbClr val="E7F0F5"/>
                 </a:solidFill>
                 <a:latin typeface="Calibri"/>
               </a:rPr>
-              <a:t>•  Multiclass test: weighted F1 ≈ 0.998 · macro F1 ≈ 0.917</a:t>
+              <a:t>•  Multiclass test: macro-F1 0.99813 · weighted-F1 0.99979 · accuracy 0.99979</a:t>
             </a:r>
           </a:p>
           <a:p>
             <a:pPr>
               <a:spcAft>
-                <a:spcPts val="1000"/>
+                <a:spcPts val="800"/>
               </a:spcAft>
             </a:pPr>
             <a:r>
-              <a:rPr sz="2200" b="0">
+              <a:rPr sz="1900" b="0">
                 <a:solidFill>
                   <a:srgbClr val="E7F0F5"/>
                 </a:solidFill>
                 <a:latin typeface="Calibri"/>
               </a:rPr>
-              <a:t>•  Compared LR, Decision Tree, Random Forest, XGBoost</a:t>
+              <a:t>•  Candidates compared: LR, Decision Tree, Random Forest, XGBoost</a:t>
             </a:r>
           </a:p>
           <a:p>
             <a:pPr>
               <a:spcAft>
-                <a:spcPts val="1000"/>
+                <a:spcPts val="800"/>
               </a:spcAft>
             </a:pPr>
             <a:r>
-              <a:rPr sz="2200" b="0">
+              <a:rPr sz="1900" b="0">
                 <a:solidFill>
                   <a:srgbClr val="E7F0F5"/>
                 </a:solidFill>
                 <a:latin typeface="Calibri"/>
               </a:rPr>
-              <a:t>•  For IDS, recall/precision/F1 matter more than raw accuracy</a:t>
+              <a:t>•  IID benchmark strength ≠ live-deployment performance guarantee</a:t>
             </a:r>
           </a:p>
         </p:txBody>
@@ -4795,7 +5562,7 @@
                 </a:solidFill>
                 <a:latin typeface="Calibri"/>
               </a:rPr>
-              <a:t>Evaluation figures</a:t>
+              <a:t>Why Decision Tree (not XGBoost)?</a:t>
             </a:r>
           </a:p>
         </p:txBody>
@@ -4809,7 +5576,7 @@
         <p:spPr>
           <a:xfrm>
             <a:off x="548640" y="1005840"/>
-            <a:ext cx="10972800" cy="548640"/>
+            <a:ext cx="10972800" cy="502920"/>
           </a:xfrm>
           <a:prstGeom prst="rect">
             <a:avLst/>
@@ -4823,20 +5590,107 @@
           <a:lstStyle/>
           <a:p>
             <a:r>
-              <a:rPr sz="1600" b="0">
+              <a:rPr sz="1500" b="0">
                 <a:solidFill>
                   <a:srgbClr val="8FA6B5"/>
                 </a:solidFill>
                 <a:latin typeface="Calibri"/>
               </a:rPr>
-              <a:t>Confusion matrix &amp; ROC</a:t>
+              <a:t>Multi-objective selection — recall first</a:t>
+            </a:r>
+          </a:p>
+        </p:txBody>
+      </p:sp>
+      <p:sp>
+        <p:nvSpPr>
+          <p:cNvPr id="5" name="TextBox 4"/>
+          <p:cNvSpPr txBox="1"/>
+          <p:nvPr/>
+        </p:nvSpPr>
+        <p:spPr>
+          <a:xfrm>
+            <a:off x="548640" y="1691640"/>
+            <a:ext cx="5943600" cy="4754880"/>
+          </a:xfrm>
+          <a:prstGeom prst="rect">
+            <a:avLst/>
+          </a:prstGeom>
+          <a:noFill/>
+        </p:spPr>
+        <p:txBody>
+          <a:bodyPr wrap="square">
+            <a:spAutoFit/>
+          </a:bodyPr>
+          <a:lstStyle/>
+          <a:p>
+            <a:pPr>
+              <a:spcAft>
+                <a:spcPts val="800"/>
+              </a:spcAft>
+            </a:pPr>
+            <a:r>
+              <a:rPr sz="1800" b="0">
+                <a:solidFill>
+                  <a:srgbClr val="E7F0F5"/>
+                </a:solidFill>
+                <a:latin typeface="Calibri"/>
+              </a:rPr>
+              <a:t>•  Weights: recall 0.30 · F1 0.25 · PR-AUC 0.20 · FPR 0.15 · latency 0.10</a:t>
+            </a:r>
+          </a:p>
+          <a:p>
+            <a:pPr>
+              <a:spcAft>
+                <a:spcPts val="800"/>
+              </a:spcAft>
+            </a:pPr>
+            <a:r>
+              <a:rPr sz="1800" b="0">
+                <a:solidFill>
+                  <a:srgbClr val="E7F0F5"/>
+                </a:solidFill>
+                <a:latin typeface="Calibri"/>
+              </a:rPr>
+              <a:t>•  XGBoost can win raw F1; Decision Tree wins attack recall → selected</a:t>
+            </a:r>
+          </a:p>
+          <a:p>
+            <a:pPr>
+              <a:spcAft>
+                <a:spcPts val="800"/>
+              </a:spcAft>
+            </a:pPr>
+            <a:r>
+              <a:rPr sz="1800" b="0">
+                <a:solidFill>
+                  <a:srgbClr val="E7F0F5"/>
+                </a:solidFill>
+                <a:latin typeface="Calibri"/>
+              </a:rPr>
+              <a:t>•  Multiclass: Random Forest edges XGBoost on macro/weighted blend</a:t>
+            </a:r>
+          </a:p>
+          <a:p>
+            <a:pPr>
+              <a:spcAft>
+                <a:spcPts val="800"/>
+              </a:spcAft>
+            </a:pPr>
+            <a:r>
+              <a:rPr sz="1800" b="0">
+                <a:solidFill>
+                  <a:srgbClr val="E7F0F5"/>
+                </a:solidFill>
+                <a:latin typeface="Calibri"/>
+              </a:rPr>
+              <a:t>•  For IDS, missed attacks (FN) are costly — policy matters</a:t>
             </a:r>
           </a:p>
         </p:txBody>
       </p:sp>
       <p:pic>
         <p:nvPicPr>
-          <p:cNvPr id="5" name="Picture 4" descr="binary_confusion_matrix.png"/>
+          <p:cNvPr id="6" name="Picture 5" descr="model_binary_f1_vs_recall.png"/>
           <p:cNvPicPr>
             <a:picLocks noChangeAspect="1"/>
           </p:cNvPicPr>
@@ -4850,32 +5704,8 @@
         </p:blipFill>
         <p:spPr>
           <a:xfrm>
-            <a:off x="548640" y="1645920"/>
-            <a:ext cx="5486400" cy="4389120"/>
-          </a:xfrm>
-          <a:prstGeom prst="rect">
-            <a:avLst/>
-          </a:prstGeom>
-        </p:spPr>
-      </p:pic>
-      <p:pic>
-        <p:nvPicPr>
-          <p:cNvPr id="6" name="Picture 5" descr="binary_roc.png"/>
-          <p:cNvPicPr>
-            <a:picLocks noChangeAspect="1"/>
-          </p:cNvPicPr>
-          <p:nvPr/>
-        </p:nvPicPr>
-        <p:blipFill>
-          <a:blip r:embed="rId3"/>
-          <a:stretch>
-            <a:fillRect/>
-          </a:stretch>
-        </p:blipFill>
-        <p:spPr>
-          <a:xfrm>
-            <a:off x="6217920" y="1645920"/>
-            <a:ext cx="5486400" cy="4389120"/>
+            <a:off x="6583680" y="1737360"/>
+            <a:ext cx="5120640" cy="3413760"/>
           </a:xfrm>
           <a:prstGeom prst="rect">
             <a:avLst/>
@@ -4972,7 +5802,7 @@
                 </a:solidFill>
                 <a:latin typeface="Calibri"/>
               </a:rPr>
-              <a:t>Explainability (RQ2 / RQ3)</a:t>
+              <a:t>Evaluation figures</a:t>
             </a:r>
           </a:p>
         </p:txBody>
@@ -4985,8 +5815,8 @@
         </p:nvSpPr>
         <p:spPr>
           <a:xfrm>
-            <a:off x="640080" y="1737360"/>
-            <a:ext cx="10972800" cy="4754880"/>
+            <a:off x="548640" y="1005840"/>
+            <a:ext cx="10972800" cy="502920"/>
           </a:xfrm>
           <a:prstGeom prst="rect">
             <a:avLst/>
@@ -4994,79 +5824,26 @@
           <a:noFill/>
         </p:spPr>
         <p:txBody>
-          <a:bodyPr wrap="square">
+          <a:bodyPr wrap="none">
             <a:spAutoFit/>
           </a:bodyPr>
           <a:lstStyle/>
           <a:p>
-            <a:pPr>
-              <a:spcAft>
-                <a:spcPts val="1000"/>
-              </a:spcAft>
-            </a:pPr>
-            <a:r>
-              <a:rPr sz="2200" b="0">
-                <a:solidFill>
-                  <a:srgbClr val="E7F0F5"/>
-                </a:solidFill>
-                <a:latin typeface="Calibri"/>
-              </a:rPr>
-              <a:t>•  SHAP: feature contributions for each prediction (primary)</a:t>
-            </a:r>
-          </a:p>
-          <a:p>
-            <a:pPr>
-              <a:spcAft>
-                <a:spcPts val="1000"/>
-              </a:spcAft>
-            </a:pPr>
-            <a:r>
-              <a:rPr sz="2200" b="0">
-                <a:solidFill>
-                  <a:srgbClr val="E7F0F5"/>
-                </a:solidFill>
-                <a:latin typeface="Calibri"/>
-              </a:rPr>
-              <a:t>•  LIME: local surrogate explanation (secondary)</a:t>
-            </a:r>
-          </a:p>
-          <a:p>
-            <a:pPr>
-              <a:spcAft>
-                <a:spcPts val="1000"/>
-              </a:spcAft>
-            </a:pPr>
-            <a:r>
-              <a:rPr sz="2200" b="0">
-                <a:solidFill>
-                  <a:srgbClr val="E7F0F5"/>
-                </a:solidFill>
-                <a:latin typeface="Calibri"/>
-              </a:rPr>
-              <a:t>•  Live demo: Detection → Why? → SHAP / LIME tabs</a:t>
-            </a:r>
-          </a:p>
-          <a:p>
-            <a:pPr>
-              <a:spcAft>
-                <a:spcPts val="1000"/>
-              </a:spcAft>
-            </a:pPr>
-            <a:r>
-              <a:rPr sz="2200" b="0">
-                <a:solidFill>
-                  <a:srgbClr val="E7F0F5"/>
-                </a:solidFill>
-                <a:latin typeface="Calibri"/>
-              </a:rPr>
-              <a:t>•  Supports analyst trust — not treated as causal proof</a:t>
+            <a:r>
+              <a:rPr sz="1500" b="0">
+                <a:solidFill>
+                  <a:srgbClr val="8FA6B5"/>
+                </a:solidFill>
+                <a:latin typeface="Calibri"/>
+              </a:rPr>
+              <a:t>IID test confusion matrix &amp; ROC</a:t>
             </a:r>
           </a:p>
         </p:txBody>
       </p:sp>
       <p:pic>
         <p:nvPicPr>
-          <p:cNvPr id="5" name="Picture 4" descr="feature_importance.png"/>
+          <p:cNvPr id="5" name="Picture 4" descr="binary_confusion_matrix.png"/>
           <p:cNvPicPr>
             <a:picLocks noChangeAspect="1"/>
           </p:cNvPicPr>
@@ -5080,8 +5857,32 @@
         </p:blipFill>
         <p:spPr>
           <a:xfrm>
-            <a:off x="6583680" y="1828800"/>
-            <a:ext cx="5029200" cy="3143250"/>
+            <a:off x="457200" y="1554480"/>
+            <a:ext cx="5715000" cy="4572000"/>
+          </a:xfrm>
+          <a:prstGeom prst="rect">
+            <a:avLst/>
+          </a:prstGeom>
+        </p:spPr>
+      </p:pic>
+      <p:pic>
+        <p:nvPicPr>
+          <p:cNvPr id="6" name="Picture 5" descr="binary_roc.png"/>
+          <p:cNvPicPr>
+            <a:picLocks noChangeAspect="1"/>
+          </p:cNvPicPr>
+          <p:nvPr/>
+        </p:nvPicPr>
+        <p:blipFill>
+          <a:blip r:embed="rId3"/>
+          <a:stretch>
+            <a:fillRect/>
+          </a:stretch>
+        </p:blipFill>
+        <p:spPr>
+          <a:xfrm>
+            <a:off x="6309360" y="1554480"/>
+            <a:ext cx="5715000" cy="4572000"/>
           </a:xfrm>
           <a:prstGeom prst="rect">
             <a:avLst/>
@@ -5178,7 +5979,7 @@
                 </a:solidFill>
                 <a:latin typeface="Calibri"/>
               </a:rPr>
-              <a:t>Risk &amp; recommendations (RQ4)</a:t>
+              <a:t>Temporal generalization</a:t>
             </a:r>
           </a:p>
         </p:txBody>
@@ -5191,8 +5992,8 @@
         </p:nvSpPr>
         <p:spPr>
           <a:xfrm>
-            <a:off x="640080" y="1737360"/>
-            <a:ext cx="10972800" cy="4754880"/>
+            <a:off x="548640" y="1005840"/>
+            <a:ext cx="10972800" cy="502920"/>
           </a:xfrm>
           <a:prstGeom prst="rect">
             <a:avLst/>
@@ -5200,6 +6001,40 @@
           <a:noFill/>
         </p:spPr>
         <p:txBody>
+          <a:bodyPr wrap="none">
+            <a:spAutoFit/>
+          </a:bodyPr>
+          <a:lstStyle/>
+          <a:p>
+            <a:r>
+              <a:rPr sz="1500" b="0">
+                <a:solidFill>
+                  <a:srgbClr val="8FA6B5"/>
+                </a:solidFill>
+                <a:latin typeface="Calibri"/>
+              </a:rPr>
+              <a:t>Frozen models · day-aware Friday holdout · no retrain</a:t>
+            </a:r>
+          </a:p>
+        </p:txBody>
+      </p:sp>
+      <p:sp>
+        <p:nvSpPr>
+          <p:cNvPr id="5" name="TextBox 4"/>
+          <p:cNvSpPr txBox="1"/>
+          <p:nvPr/>
+        </p:nvSpPr>
+        <p:spPr>
+          <a:xfrm>
+            <a:off x="548640" y="1691640"/>
+            <a:ext cx="6035040" cy="4754880"/>
+          </a:xfrm>
+          <a:prstGeom prst="rect">
+            <a:avLst/>
+          </a:prstGeom>
+          <a:noFill/>
+        </p:spPr>
+        <p:txBody>
           <a:bodyPr wrap="square">
             <a:spAutoFit/>
           </a:bodyPr>
@@ -5207,69 +6042,93 @@
           <a:p>
             <a:pPr>
               <a:spcAft>
-                <a:spcPts val="1000"/>
+                <a:spcPts val="800"/>
               </a:spcAft>
             </a:pPr>
             <a:r>
-              <a:rPr sz="2200" b="0">
+              <a:rPr sz="1700" b="0">
                 <a:solidFill>
                   <a:srgbClr val="E7F0F5"/>
                 </a:solidFill>
                 <a:latin typeface="Calibri"/>
               </a:rPr>
-              <a:t>•  Risk blends attack-family base + confidence + traffic intensity</a:t>
+              <a:t>•  Friday sample (n=36k, attack rate ~34%): binary F1 0.9977</a:t>
             </a:r>
           </a:p>
           <a:p>
             <a:pPr>
               <a:spcAft>
-                <a:spcPts val="1000"/>
+                <a:spcPts val="800"/>
               </a:spcAft>
             </a:pPr>
             <a:r>
-              <a:rPr sz="2200" b="0">
+              <a:rPr sz="1700" b="0">
                 <a:solidFill>
                   <a:srgbClr val="E7F0F5"/>
                 </a:solidFill>
                 <a:latin typeface="Calibri"/>
               </a:rPr>
-              <a:t>•  Severity bands: LOW / MEDIUM / HIGH / CRITICAL (configurable)</a:t>
+              <a:t>•  Mon–Thu sample (n=60k, ~7% attacks): binary F1 0.980 — mild drop</a:t>
             </a:r>
           </a:p>
           <a:p>
             <a:pPr>
               <a:spcAft>
-                <a:spcPts val="1000"/>
+                <a:spcPts val="800"/>
               </a:spcAft>
             </a:pPr>
             <a:r>
-              <a:rPr sz="2200" b="0">
+              <a:rPr sz="1700" b="0">
                 <a:solidFill>
                   <a:srgbClr val="E7F0F5"/>
                 </a:solidFill>
                 <a:latin typeface="Calibri"/>
               </a:rPr>
-              <a:t>•  Playbooks: rate limiting, filtering, WAF, isolation, …</a:t>
+              <a:t>•  Friday multiclass only Bot/DDoS/PortScan — not a 6-class temporal claim</a:t>
             </a:r>
           </a:p>
           <a:p>
             <a:pPr>
               <a:spcAft>
-                <a:spcPts val="1000"/>
+                <a:spcPts val="800"/>
               </a:spcAft>
             </a:pPr>
             <a:r>
-              <a:rPr sz="2200" b="0">
+              <a:rPr sz="1700" b="0">
                 <a:solidFill>
                   <a:srgbClr val="E7F0F5"/>
                 </a:solidFill>
                 <a:latin typeface="Calibri"/>
               </a:rPr>
-              <a:t>•  Advisory only — platform does not auto-block real networks</a:t>
-            </a:r>
-          </a:p>
-        </p:txBody>
-      </p:sp>
+              <a:t>•  Message: IID strength ≠ automatic temporal / live generalization</a:t>
+            </a:r>
+          </a:p>
+        </p:txBody>
+      </p:sp>
+      <p:pic>
+        <p:nvPicPr>
+          <p:cNvPr id="6" name="Picture 5" descr="temporal_generalization_summary.png"/>
+          <p:cNvPicPr>
+            <a:picLocks noChangeAspect="1"/>
+          </p:cNvPicPr>
+          <p:nvPr/>
+        </p:nvPicPr>
+        <p:blipFill>
+          <a:blip r:embed="rId2"/>
+          <a:stretch>
+            <a:fillRect/>
+          </a:stretch>
+        </p:blipFill>
+        <p:spPr>
+          <a:xfrm>
+            <a:off x="6492240" y="1691640"/>
+            <a:ext cx="5212080" cy="2943292"/>
+          </a:xfrm>
+          <a:prstGeom prst="rect">
+            <a:avLst/>
+          </a:prstGeom>
+        </p:spPr>
+      </p:pic>
     </p:spTree>
   </p:cSld>
   <p:clrMapOvr>

</xml_diff>

<commit_message>
Generate final 18-slide viva presentation aligned to PROJECT_REPORT.md.
Co-authored-by: Cursor <cursoragent@cursor.com>
</commit_message>
<xml_diff>
--- a/docs/Aegis_IDS_Viva_Presentation.pptx
+++ b/docs/Aegis_IDS_Viva_Presentation.pptx
@@ -20,6 +20,9 @@
     <p:sldId id="268" r:id="rId19"/>
     <p:sldId id="269" r:id="rId20"/>
     <p:sldId id="270" r:id="rId21"/>
+    <p:sldId id="271" r:id="rId22"/>
+    <p:sldId id="272" r:id="rId23"/>
+    <p:sldId id="273" r:id="rId24"/>
   </p:sldIdLst>
   <p:sldSz cx="12191695" cy="6858000" type="screen4x3"/>
   <p:notesSz cx="6858000" cy="9144000"/>
@@ -3153,8 +3156,8 @@
         </p:nvSpPr>
         <p:spPr>
           <a:xfrm>
-            <a:off x="731520" y="1645920"/>
-            <a:ext cx="10515600" cy="3657600"/>
+            <a:off x="731520" y="1371600"/>
+            <a:ext cx="10698480" cy="4114800"/>
           </a:xfrm>
           <a:prstGeom prst="rect">
             <a:avLst/>
@@ -3194,14 +3197,15 @@
           <a:p>
             <a:pPr algn="ctr"/>
             <a:r>
-              <a:rPr sz="1600" b="0">
+              <a:rPr sz="1500" b="0">
                 <a:solidFill>
                   <a:srgbClr val="8FA6B5"/>
                 </a:solidFill>
                 <a:latin typeface="Calibri"/>
               </a:rPr>
               <a:t>
-Frozen v1.1  ·  Decision Tree @ 0.85  ·  Random Forest (attack-only)</a:t>
+v1.1-research  →  v2.0-aegis-productionized
+Decision Tree @ 0.85  ·  Random Forest (attack-only)  ·  P12 PASS</a:t>
             </a:r>
           </a:p>
           <a:p>
@@ -3213,7 +3217,8 @@
                 </a:solidFill>
                 <a:latin typeface="Calibri"/>
               </a:rPr>
-              <a:t>Team members  ·  College  ·  Year</a:t>
+              <a:t>
+Team members  ·  College  ·  Year</a:t>
             </a:r>
           </a:p>
         </p:txBody>
@@ -3288,7 +3293,7 @@
         <p:spPr>
           <a:xfrm>
             <a:off x="548640" y="320040"/>
-            <a:ext cx="10972800" cy="914400"/>
+            <a:ext cx="11155680" cy="914400"/>
           </a:xfrm>
           <a:prstGeom prst="rect">
             <a:avLst/>
@@ -3302,13 +3307,13 @@
           <a:lstStyle/>
           <a:p>
             <a:r>
-              <a:rPr sz="3200" b="1">
+              <a:rPr sz="3000" b="1">
                 <a:solidFill>
                   <a:srgbClr val="3EC7C2"/>
                 </a:solidFill>
                 <a:latin typeface="Calibri"/>
               </a:rPr>
-              <a:t>Drift &amp; residual errors</a:t>
+              <a:t>Why Decision Tree (not XGBoost)?</a:t>
             </a:r>
           </a:p>
         </p:txBody>
@@ -3321,8 +3326,8 @@
         </p:nvSpPr>
         <p:spPr>
           <a:xfrm>
-            <a:off x="548640" y="1005840"/>
-            <a:ext cx="10972800" cy="502920"/>
+            <a:off x="548640" y="960120"/>
+            <a:ext cx="11155680" cy="457200"/>
           </a:xfrm>
           <a:prstGeom prst="rect">
             <a:avLst/>
@@ -3336,13 +3341,13 @@
           <a:lstStyle/>
           <a:p>
             <a:r>
-              <a:rPr sz="1500" b="0">
+              <a:rPr sz="1400" b="0">
                 <a:solidFill>
                   <a:srgbClr val="8FA6B5"/>
                 </a:solidFill>
                 <a:latin typeface="Calibri"/>
               </a:rPr>
-              <a:t>IID monitoring + confusion structure</a:t>
+              <a:t>Multi-objective selection — recall first</a:t>
             </a:r>
           </a:p>
         </p:txBody>
@@ -3355,8 +3360,8 @@
         </p:nvSpPr>
         <p:spPr>
           <a:xfrm>
-            <a:off x="548640" y="1691640"/>
-            <a:ext cx="6035040" cy="4754880"/>
+            <a:off x="502920" y="1554480"/>
+            <a:ext cx="5943600" cy="4937760"/>
           </a:xfrm>
           <a:prstGeom prst="rect">
             <a:avLst/>
@@ -3371,72 +3376,72 @@
           <a:p>
             <a:pPr>
               <a:spcAft>
-                <a:spcPts val="800"/>
+                <a:spcPts val="700"/>
               </a:spcAft>
             </a:pPr>
             <a:r>
-              <a:rPr sz="1700" b="0">
+              <a:rPr sz="1600" b="0">
                 <a:solidFill>
                   <a:srgbClr val="E7F0F5"/>
                 </a:solidFill>
                 <a:latin typeface="Calibri"/>
               </a:rPr>
-              <a:t>•  Train→test IID drift: 0 features with PSI ≥ 0.2 (expected same-corpus)</a:t>
+              <a:t>•  Weights: recall 0.30 · F1 0.25 · PR-AUC 0.20 · FPR 0.15 · latency 0.10</a:t>
             </a:r>
           </a:p>
           <a:p>
             <a:pPr>
               <a:spcAft>
-                <a:spcPts val="800"/>
+                <a:spcPts val="700"/>
               </a:spcAft>
             </a:pPr>
             <a:r>
-              <a:rPr sz="1700" b="0">
+              <a:rPr sz="1600" b="0">
                 <a:solidFill>
                   <a:srgbClr val="E7F0F5"/>
                 </a:solidFill>
                 <a:latin typeface="Calibri"/>
               </a:rPr>
-              <a:t>•  Binary residuals: FP 1,377 · FN 255 (FPR 0.00329 / FNR 0.00300)</a:t>
+              <a:t>•  XGBoost can win raw F1; Decision Tree wins attack recall → selected</a:t>
             </a:r>
           </a:p>
           <a:p>
             <a:pPr>
               <a:spcAft>
-                <a:spcPts val="800"/>
+                <a:spcPts val="700"/>
               </a:spcAft>
             </a:pPr>
             <a:r>
-              <a:rPr sz="1700" b="0">
+              <a:rPr sz="1600" b="0">
                 <a:solidFill>
                   <a:srgbClr val="E7F0F5"/>
                 </a:solidFill>
                 <a:latin typeface="Calibri"/>
               </a:rPr>
-              <a:t>•  Multiclass: 18 errors / 85,139 attacks — PortScan / DoS / WebAttack</a:t>
+              <a:t>•  Multiclass: Random Forest edges XGBoost on macro/weighted blend</a:t>
             </a:r>
           </a:p>
           <a:p>
             <a:pPr>
               <a:spcAft>
-                <a:spcPts val="800"/>
+                <a:spcPts val="700"/>
               </a:spcAft>
             </a:pPr>
             <a:r>
-              <a:rPr sz="1700" b="0">
+              <a:rPr sz="1600" b="0">
                 <a:solidFill>
                   <a:srgbClr val="E7F0F5"/>
                 </a:solidFill>
                 <a:latin typeface="Calibri"/>
               </a:rPr>
-              <a:t>•  PSI≈0 ≠ live drift absence · external dataset = future work</a:t>
+              <a:t>•  For IDS, missed attacks (FN) are costly — selection policy matters</a:t>
             </a:r>
           </a:p>
         </p:txBody>
       </p:sp>
       <p:pic>
         <p:nvPicPr>
-          <p:cNvPr id="6" name="Picture 5" descr="error_multiclass_top_confusions.png"/>
+          <p:cNvPr id="6" name="Picture 5" descr="model_binary_f1_vs_recall.png"/>
           <p:cNvPicPr>
             <a:picLocks noChangeAspect="1"/>
           </p:cNvPicPr>
@@ -3450,14 +3455,48 @@
         </p:blipFill>
         <p:spPr>
           <a:xfrm>
-            <a:off x="6492240" y="1691640"/>
-            <a:ext cx="5212080" cy="2931795"/>
+            <a:off x="6583680" y="1691640"/>
+            <a:ext cx="5120640" cy="3413760"/>
           </a:xfrm>
           <a:prstGeom prst="rect">
             <a:avLst/>
           </a:prstGeom>
         </p:spPr>
       </p:pic>
+      <p:sp>
+        <p:nvSpPr>
+          <p:cNvPr id="7" name="TextBox 6"/>
+          <p:cNvSpPr txBox="1"/>
+          <p:nvPr/>
+        </p:nvSpPr>
+        <p:spPr>
+          <a:xfrm>
+            <a:off x="548640" y="6446520"/>
+            <a:ext cx="11155680" cy="320040"/>
+          </a:xfrm>
+          <a:prstGeom prst="rect">
+            <a:avLst/>
+          </a:prstGeom>
+          <a:noFill/>
+        </p:spPr>
+        <p:txBody>
+          <a:bodyPr wrap="none">
+            <a:spAutoFit/>
+          </a:bodyPr>
+          <a:lstStyle/>
+          <a:p>
+            <a:r>
+              <a:rPr sz="1100" b="0">
+                <a:solidFill>
+                  <a:srgbClr val="8FA6B5"/>
+                </a:solidFill>
+                <a:latin typeface="Calibri"/>
+              </a:rPr>
+              <a:t>Aegis IDS  ·  v2.0-aegis-productionized  ·  Research baseline v1.1-research</a:t>
+            </a:r>
+          </a:p>
+        </p:txBody>
+      </p:sp>
     </p:spTree>
   </p:cSld>
   <p:clrMapOvr>
@@ -3528,7 +3567,7 @@
         <p:spPr>
           <a:xfrm>
             <a:off x="548640" y="320040"/>
-            <a:ext cx="10972800" cy="914400"/>
+            <a:ext cx="11155680" cy="914400"/>
           </a:xfrm>
           <a:prstGeom prst="rect">
             <a:avLst/>
@@ -3542,13 +3581,13 @@
           <a:lstStyle/>
           <a:p>
             <a:r>
-              <a:rPr sz="3200" b="1">
+              <a:rPr sz="3000" b="1">
                 <a:solidFill>
                   <a:srgbClr val="3EC7C2"/>
                 </a:solidFill>
                 <a:latin typeface="Calibri"/>
               </a:rPr>
-              <a:t>Explainability (RQ2 / RQ3)</a:t>
+              <a:t>Explainability &amp; risk</a:t>
             </a:r>
           </a:p>
         </p:txBody>
@@ -3561,8 +3600,42 @@
         </p:nvSpPr>
         <p:spPr>
           <a:xfrm>
-            <a:off x="548640" y="1691640"/>
-            <a:ext cx="5943600" cy="4754880"/>
+            <a:off x="548640" y="960120"/>
+            <a:ext cx="11155680" cy="457200"/>
+          </a:xfrm>
+          <a:prstGeom prst="rect">
+            <a:avLst/>
+          </a:prstGeom>
+          <a:noFill/>
+        </p:spPr>
+        <p:txBody>
+          <a:bodyPr wrap="none">
+            <a:spAutoFit/>
+          </a:bodyPr>
+          <a:lstStyle/>
+          <a:p>
+            <a:r>
+              <a:rPr sz="1400" b="0">
+                <a:solidFill>
+                  <a:srgbClr val="8FA6B5"/>
+                </a:solidFill>
+                <a:latin typeface="Calibri"/>
+              </a:rPr>
+              <a:t>Decision support — not causality</a:t>
+            </a:r>
+          </a:p>
+        </p:txBody>
+      </p:sp>
+      <p:sp>
+        <p:nvSpPr>
+          <p:cNvPr id="5" name="TextBox 4"/>
+          <p:cNvSpPr txBox="1"/>
+          <p:nvPr/>
+        </p:nvSpPr>
+        <p:spPr>
+          <a:xfrm>
+            <a:off x="502920" y="1554480"/>
+            <a:ext cx="5943600" cy="4937760"/>
           </a:xfrm>
           <a:prstGeom prst="rect">
             <a:avLst/>
@@ -3577,72 +3650,72 @@
           <a:p>
             <a:pPr>
               <a:spcAft>
-                <a:spcPts val="800"/>
+                <a:spcPts val="700"/>
               </a:spcAft>
             </a:pPr>
             <a:r>
-              <a:rPr sz="1800" b="0">
+              <a:rPr sz="1600" b="0">
                 <a:solidFill>
                   <a:srgbClr val="E7F0F5"/>
                 </a:solidFill>
                 <a:latin typeface="Calibri"/>
               </a:rPr>
-              <a:t>•  SHAP: feature contributions for each prediction (primary)</a:t>
+              <a:t>•  SHAP primary · LIME secondary (Detection → Why? tabs)</a:t>
             </a:r>
           </a:p>
           <a:p>
             <a:pPr>
               <a:spcAft>
-                <a:spcPts val="800"/>
+                <a:spcPts val="700"/>
               </a:spcAft>
             </a:pPr>
             <a:r>
-              <a:rPr sz="1800" b="0">
+              <a:rPr sz="1600" b="0">
                 <a:solidFill>
                   <a:srgbClr val="E7F0F5"/>
                 </a:solidFill>
                 <a:latin typeface="Calibri"/>
               </a:rPr>
-              <a:t>•  LIME: local surrogate explanation (secondary)</a:t>
+              <a:t>•  Risk blend: 50% attack base · 25% confidence · 15% intensity · 10% asset</a:t>
             </a:r>
           </a:p>
           <a:p>
             <a:pPr>
               <a:spcAft>
-                <a:spcPts val="800"/>
+                <a:spcPts val="700"/>
               </a:spcAft>
             </a:pPr>
             <a:r>
-              <a:rPr sz="1800" b="0">
+              <a:rPr sz="1600" b="0">
                 <a:solidFill>
                   <a:srgbClr val="E7F0F5"/>
                 </a:solidFill>
                 <a:latin typeface="Calibri"/>
               </a:rPr>
-              <a:t>•  Live demo: Detection → Why? → SHAP / LIME tabs</a:t>
+              <a:t>•  Severity bands: LOW / MEDIUM / HIGH / CRITICAL (project conventions)</a:t>
             </a:r>
           </a:p>
           <a:p>
             <a:pPr>
               <a:spcAft>
-                <a:spcPts val="800"/>
+                <a:spcPts val="700"/>
               </a:spcAft>
             </a:pPr>
             <a:r>
-              <a:rPr sz="1800" b="0">
+              <a:rPr sz="1600" b="0">
                 <a:solidFill>
                   <a:srgbClr val="E7F0F5"/>
                 </a:solidFill>
                 <a:latin typeface="Calibri"/>
               </a:rPr>
-              <a:t>•  Decision support — not treated as causal proof</a:t>
+              <a:t>•  Recommendations are advisory until human approval</a:t>
             </a:r>
           </a:p>
         </p:txBody>
       </p:sp>
       <p:pic>
         <p:nvPicPr>
-          <p:cNvPr id="5" name="Picture 4" descr="feature_importance.png"/>
+          <p:cNvPr id="6" name="Picture 5" descr="feature_importance.png"/>
           <p:cNvPicPr>
             <a:picLocks noChangeAspect="1"/>
           </p:cNvPicPr>
@@ -3656,7 +3729,7 @@
         </p:blipFill>
         <p:spPr>
           <a:xfrm>
-            <a:off x="6583680" y="1737360"/>
+            <a:off x="6583680" y="1691640"/>
             <a:ext cx="5029200" cy="3143250"/>
           </a:xfrm>
           <a:prstGeom prst="rect">
@@ -3664,6 +3737,40 @@
           </a:prstGeom>
         </p:spPr>
       </p:pic>
+      <p:sp>
+        <p:nvSpPr>
+          <p:cNvPr id="7" name="TextBox 6"/>
+          <p:cNvSpPr txBox="1"/>
+          <p:nvPr/>
+        </p:nvSpPr>
+        <p:spPr>
+          <a:xfrm>
+            <a:off x="548640" y="6446520"/>
+            <a:ext cx="11155680" cy="320040"/>
+          </a:xfrm>
+          <a:prstGeom prst="rect">
+            <a:avLst/>
+          </a:prstGeom>
+          <a:noFill/>
+        </p:spPr>
+        <p:txBody>
+          <a:bodyPr wrap="none">
+            <a:spAutoFit/>
+          </a:bodyPr>
+          <a:lstStyle/>
+          <a:p>
+            <a:r>
+              <a:rPr sz="1100" b="0">
+                <a:solidFill>
+                  <a:srgbClr val="8FA6B5"/>
+                </a:solidFill>
+                <a:latin typeface="Calibri"/>
+              </a:rPr>
+              <a:t>Aegis IDS  ·  v2.0-aegis-productionized  ·  Research baseline v1.1-research</a:t>
+            </a:r>
+          </a:p>
+        </p:txBody>
+      </p:sp>
     </p:spTree>
   </p:cSld>
   <p:clrMapOvr>
@@ -3734,7 +3841,7 @@
         <p:spPr>
           <a:xfrm>
             <a:off x="548640" y="320040"/>
-            <a:ext cx="10972800" cy="914400"/>
+            <a:ext cx="11155680" cy="914400"/>
           </a:xfrm>
           <a:prstGeom prst="rect">
             <a:avLst/>
@@ -3748,13 +3855,13 @@
           <a:lstStyle/>
           <a:p>
             <a:r>
-              <a:rPr sz="3200" b="1">
+              <a:rPr sz="3000" b="1">
                 <a:solidFill>
                   <a:srgbClr val="3EC7C2"/>
                 </a:solidFill>
                 <a:latin typeface="Calibri"/>
               </a:rPr>
-              <a:t>Risk &amp; recommendations (RQ4)</a:t>
+              <a:t>Attack–defense simulation</a:t>
             </a:r>
           </a:p>
         </p:txBody>
@@ -3767,8 +3874,42 @@
         </p:nvSpPr>
         <p:spPr>
           <a:xfrm>
-            <a:off x="640080" y="1691640"/>
-            <a:ext cx="10972800" cy="4754880"/>
+            <a:off x="548640" y="960120"/>
+            <a:ext cx="11155680" cy="457200"/>
+          </a:xfrm>
+          <a:prstGeom prst="rect">
+            <a:avLst/>
+          </a:prstGeom>
+          <a:noFill/>
+        </p:spPr>
+        <p:txBody>
+          <a:bodyPr wrap="none">
+            <a:spAutoFit/>
+          </a:bodyPr>
+          <a:lstStyle/>
+          <a:p>
+            <a:r>
+              <a:rPr sz="1400" b="0">
+                <a:solidFill>
+                  <a:srgbClr val="8FA6B5"/>
+                </a:solidFill>
+                <a:latin typeface="Calibri"/>
+              </a:rPr>
+              <a:t>Visualization only — assumptions ≠ measurements</a:t>
+            </a:r>
+          </a:p>
+        </p:txBody>
+      </p:sp>
+      <p:sp>
+        <p:nvSpPr>
+          <p:cNvPr id="5" name="TextBox 4"/>
+          <p:cNvSpPr txBox="1"/>
+          <p:nvPr/>
+        </p:nvSpPr>
+        <p:spPr>
+          <a:xfrm>
+            <a:off x="640080" y="1554480"/>
+            <a:ext cx="10972800" cy="4937760"/>
           </a:xfrm>
           <a:prstGeom prst="rect">
             <a:avLst/>
@@ -3783,65 +3924,99 @@
           <a:p>
             <a:pPr>
               <a:spcAft>
-                <a:spcPts val="800"/>
+                <a:spcPts val="700"/>
               </a:spcAft>
             </a:pPr>
             <a:r>
-              <a:rPr sz="2000" b="0">
+              <a:rPr sz="1600" b="0">
                 <a:solidFill>
                   <a:srgbClr val="E7F0F5"/>
                 </a:solidFill>
                 <a:latin typeface="Calibri"/>
               </a:rPr>
-              <a:t>•  Risk weights: 50% attack base · 25% confidence · 15% intensity · 10% asset</a:t>
+              <a:t>•  idle → normal → attack_start → attack_impact → detected → recommended → defended → recovered</a:t>
             </a:r>
           </a:p>
           <a:p>
             <a:pPr>
               <a:spcAft>
-                <a:spcPts val="800"/>
+                <a:spcPts val="700"/>
               </a:spcAft>
             </a:pPr>
             <a:r>
-              <a:rPr sz="2000" b="0">
+              <a:rPr sz="1600" b="0">
                 <a:solidFill>
                   <a:srgbClr val="E7F0F5"/>
                 </a:solidFill>
                 <a:latin typeface="Calibri"/>
               </a:rPr>
-              <a:t>•  Severity bands: LOW / MEDIUM / HIGH / CRITICAL (project conventions)</a:t>
+              <a:t>•  Topology: Attacker → Firewall → Router → Server / PCs + IDS</a:t>
             </a:r>
           </a:p>
           <a:p>
             <a:pPr>
               <a:spcAft>
-                <a:spcPts val="800"/>
+                <a:spcPts val="700"/>
               </a:spcAft>
             </a:pPr>
             <a:r>
-              <a:rPr sz="2000" b="0">
+              <a:rPr sz="1600" b="0">
                 <a:solidFill>
                   <a:srgbClr val="E7F0F5"/>
                 </a:solidFill>
                 <a:latin typeface="Calibri"/>
               </a:rPr>
-              <a:t>•  Playbooks: rate limiting, filtering, WAF, isolation, …</a:t>
+              <a:t>•  Simulation priors (examples): DDoS 0.82 · DoS 0.78 (config.yaml)</a:t>
             </a:r>
           </a:p>
           <a:p>
             <a:pPr>
               <a:spcAft>
-                <a:spcPts val="800"/>
+                <a:spcPts val="700"/>
               </a:spcAft>
             </a:pPr>
             <a:r>
-              <a:rPr sz="2000" b="0">
+              <a:rPr sz="1600" b="0">
                 <a:solidFill>
                   <a:srgbClr val="E7F0F5"/>
                 </a:solidFill>
                 <a:latin typeface="Calibri"/>
               </a:rPr>
-              <a:t>•  Advisory only — platform does not auto-block real networks</a:t>
+              <a:t>•  Safety: controlled visualization — no real cyberattacks / no live mitigation</a:t>
+            </a:r>
+          </a:p>
+        </p:txBody>
+      </p:sp>
+      <p:sp>
+        <p:nvSpPr>
+          <p:cNvPr id="6" name="TextBox 5"/>
+          <p:cNvSpPr txBox="1"/>
+          <p:nvPr/>
+        </p:nvSpPr>
+        <p:spPr>
+          <a:xfrm>
+            <a:off x="548640" y="6446520"/>
+            <a:ext cx="11155680" cy="320040"/>
+          </a:xfrm>
+          <a:prstGeom prst="rect">
+            <a:avLst/>
+          </a:prstGeom>
+          <a:noFill/>
+        </p:spPr>
+        <p:txBody>
+          <a:bodyPr wrap="none">
+            <a:spAutoFit/>
+          </a:bodyPr>
+          <a:lstStyle/>
+          <a:p>
+            <a:r>
+              <a:rPr sz="1100" b="0">
+                <a:solidFill>
+                  <a:srgbClr val="8FA6B5"/>
+                </a:solidFill>
+                <a:latin typeface="Calibri"/>
+              </a:rPr>
+              <a:t>Aegis IDS  ·  v2.0-aegis-productionized  ·  Research baseline v1.1-research</a:t>
             </a:r>
           </a:p>
         </p:txBody>
@@ -3916,7 +4091,7 @@
         <p:spPr>
           <a:xfrm>
             <a:off x="548640" y="320040"/>
-            <a:ext cx="10972800" cy="914400"/>
+            <a:ext cx="11155680" cy="914400"/>
           </a:xfrm>
           <a:prstGeom prst="rect">
             <a:avLst/>
@@ -3930,13 +4105,13 @@
           <a:lstStyle/>
           <a:p>
             <a:r>
-              <a:rPr sz="3200" b="1">
+              <a:rPr sz="3000" b="1">
                 <a:solidFill>
                   <a:srgbClr val="3EC7C2"/>
                 </a:solidFill>
                 <a:latin typeface="Calibri"/>
               </a:rPr>
-              <a:t>Simulation (RQ5) — LIVE DEMO</a:t>
+              <a:t>Controlled response architecture</a:t>
             </a:r>
           </a:p>
         </p:txBody>
@@ -3949,8 +4124,8 @@
         </p:nvSpPr>
         <p:spPr>
           <a:xfrm>
-            <a:off x="548640" y="1005840"/>
-            <a:ext cx="10972800" cy="502920"/>
+            <a:off x="548640" y="960120"/>
+            <a:ext cx="11155680" cy="457200"/>
           </a:xfrm>
           <a:prstGeom prst="rect">
             <a:avLst/>
@@ -3964,13 +4139,13 @@
           <a:lstStyle/>
           <a:p>
             <a:r>
-              <a:rPr sz="1500" b="0">
+              <a:rPr sz="1400" b="0">
                 <a:solidFill>
                   <a:srgbClr val="8FA6B5"/>
                 </a:solidFill>
                 <a:latin typeface="Calibri"/>
               </a:rPr>
-              <a:t>Attack → Detect → Defend → Recover</a:t>
+              <a:t>Human-in-the-loop safety</a:t>
             </a:r>
           </a:p>
         </p:txBody>
@@ -3983,8 +4158,8 @@
         </p:nvSpPr>
         <p:spPr>
           <a:xfrm>
-            <a:off x="640080" y="1691640"/>
-            <a:ext cx="10972800" cy="4754880"/>
+            <a:off x="640080" y="1554480"/>
+            <a:ext cx="10972800" cy="4937760"/>
           </a:xfrm>
           <a:prstGeom prst="rect">
             <a:avLst/>
@@ -3999,65 +4174,99 @@
           <a:p>
             <a:pPr>
               <a:spcAft>
-                <a:spcPts val="800"/>
+                <a:spcPts val="700"/>
               </a:spcAft>
             </a:pPr>
             <a:r>
-              <a:rPr sz="2000" b="0">
+              <a:rPr sz="1600" b="0">
                 <a:solidFill>
                   <a:srgbClr val="E7F0F5"/>
                 </a:solidFill>
                 <a:latin typeface="Calibri"/>
               </a:rPr>
-              <a:t>•  Topology: Attacker → Firewall → Router → Server / PCs + IDS</a:t>
+              <a:t>•  Lifecycle: propose → dry-run → approve → execute → verify → rollback</a:t>
             </a:r>
           </a:p>
           <a:p>
             <a:pPr>
               <a:spcAft>
-                <a:spcPts val="800"/>
+                <a:spcPts val="700"/>
               </a:spcAft>
             </a:pPr>
             <a:r>
-              <a:rPr sz="2000" b="0">
+              <a:rPr sz="1600" b="0">
                 <a:solidFill>
                   <a:srgbClr val="E7F0F5"/>
                 </a:solidFill>
                 <a:latin typeface="Calibri"/>
               </a:rPr>
-              <a:t>•  Step: normal → attack → impact → IDS alert → defense → recovery</a:t>
+              <a:t>•  Modes: DRY_RUN · CONTROLLED (TestNetworkAdapter) · LIVE forbidden</a:t>
             </a:r>
           </a:p>
           <a:p>
             <a:pPr>
               <a:spcAft>
-                <a:spcPts val="800"/>
+                <a:spcPts val="700"/>
               </a:spcAft>
             </a:pPr>
             <a:r>
-              <a:rPr sz="2000" b="0">
+              <a:rPr sz="1600" b="0">
                 <a:solidFill>
                   <a:srgbClr val="E7F0F5"/>
                 </a:solidFill>
                 <a:latin typeface="Calibri"/>
               </a:rPr>
-              <a:t>•  Defense effectiveness values are simulation assumptions</a:t>
+              <a:t>•  RBAC: viewer (read) · analyst (propose) · responder/admin (approve/rollback)</a:t>
             </a:r>
           </a:p>
           <a:p>
             <a:pPr>
               <a:spcAft>
-                <a:spcPts val="800"/>
+                <a:spcPts val="700"/>
               </a:spcAft>
             </a:pPr>
             <a:r>
-              <a:rPr sz="2000" b="0">
+              <a:rPr sz="1600" b="0">
                 <a:solidFill>
                   <a:srgbClr val="E7F0F5"/>
                 </a:solidFill>
                 <a:latin typeface="Calibri"/>
               </a:rPr>
-              <a:t>•  Safety: controlled visualization only — no real cyberattacks</a:t>
+              <a:t>•  Verify failure → rollback · reclaim never auto-replays dangerous actions</a:t>
+            </a:r>
+          </a:p>
+        </p:txBody>
+      </p:sp>
+      <p:sp>
+        <p:nvSpPr>
+          <p:cNvPr id="6" name="TextBox 5"/>
+          <p:cNvSpPr txBox="1"/>
+          <p:nvPr/>
+        </p:nvSpPr>
+        <p:spPr>
+          <a:xfrm>
+            <a:off x="548640" y="6446520"/>
+            <a:ext cx="11155680" cy="320040"/>
+          </a:xfrm>
+          <a:prstGeom prst="rect">
+            <a:avLst/>
+          </a:prstGeom>
+          <a:noFill/>
+        </p:spPr>
+        <p:txBody>
+          <a:bodyPr wrap="none">
+            <a:spAutoFit/>
+          </a:bodyPr>
+          <a:lstStyle/>
+          <a:p>
+            <a:r>
+              <a:rPr sz="1100" b="0">
+                <a:solidFill>
+                  <a:srgbClr val="8FA6B5"/>
+                </a:solidFill>
+                <a:latin typeface="Calibri"/>
+              </a:rPr>
+              <a:t>Aegis IDS  ·  v2.0-aegis-productionized  ·  Research baseline v1.1-research</a:t>
             </a:r>
           </a:p>
         </p:txBody>
@@ -4132,7 +4341,7 @@
         <p:spPr>
           <a:xfrm>
             <a:off x="548640" y="320040"/>
-            <a:ext cx="10972800" cy="914400"/>
+            <a:ext cx="11155680" cy="914400"/>
           </a:xfrm>
           <a:prstGeom prst="rect">
             <a:avLst/>
@@ -4146,13 +4355,13 @@
           <a:lstStyle/>
           <a:p>
             <a:r>
-              <a:rPr sz="3200" b="1">
+              <a:rPr sz="3000" b="1">
                 <a:solidFill>
                   <a:srgbClr val="3EC7C2"/>
                 </a:solidFill>
                 <a:latin typeface="Calibri"/>
               </a:rPr>
-              <a:t>Limitations &amp; threats to validity</a:t>
+              <a:t>P11 — Empirical mitigation</a:t>
             </a:r>
           </a:p>
         </p:txBody>
@@ -4165,8 +4374,42 @@
         </p:nvSpPr>
         <p:spPr>
           <a:xfrm>
-            <a:off x="640080" y="1691640"/>
-            <a:ext cx="10972800" cy="4754880"/>
+            <a:off x="548640" y="960120"/>
+            <a:ext cx="11155680" cy="457200"/>
+          </a:xfrm>
+          <a:prstGeom prst="rect">
+            <a:avLst/>
+          </a:prstGeom>
+          <a:noFill/>
+        </p:spPr>
+        <p:txBody>
+          <a:bodyPr wrap="none">
+            <a:spAutoFit/>
+          </a:bodyPr>
+          <a:lstStyle/>
+          <a:p>
+            <a:r>
+              <a:rPr sz="1400" b="0">
+                <a:solidFill>
+                  <a:srgbClr val="8FA6B5"/>
+                </a:solidFill>
+                <a:latin typeface="Calibri"/>
+              </a:rPr>
+              <a:t>Controlled lab measurements vs simulation priors</a:t>
+            </a:r>
+          </a:p>
+        </p:txBody>
+      </p:sp>
+      <p:sp>
+        <p:nvSpPr>
+          <p:cNvPr id="5" name="TextBox 4"/>
+          <p:cNvSpPr txBox="1"/>
+          <p:nvPr/>
+        </p:nvSpPr>
+        <p:spPr>
+          <a:xfrm>
+            <a:off x="640080" y="1554480"/>
+            <a:ext cx="10972800" cy="4937760"/>
           </a:xfrm>
           <a:prstGeom prst="rect">
             <a:avLst/>
@@ -4181,81 +4424,149 @@
           <a:p>
             <a:pPr>
               <a:spcAft>
-                <a:spcPts val="800"/>
+                <a:spcPts val="700"/>
               </a:spcAft>
             </a:pPr>
             <a:r>
-              <a:rPr sz="1800" b="0">
+              <a:rPr sz="1600" b="0">
                 <a:solidFill>
                   <a:srgbClr val="E7F0F5"/>
                 </a:solidFill>
                 <a:latin typeface="Calibri"/>
               </a:rPr>
-              <a:t>•  CICIDS2017 age / scenario structure ≠ continuous enterprise traffic</a:t>
+              <a:t>•  Conditions: no_defense vs recommendation_only vs controlled_response (N=10)</a:t>
             </a:r>
           </a:p>
           <a:p>
             <a:pPr>
               <a:spcAft>
-                <a:spcPts val="800"/>
+                <a:spcPts val="700"/>
               </a:spcAft>
             </a:pPr>
             <a:r>
-              <a:rPr sz="1800" b="0">
+              <a:rPr sz="1600" b="0">
                 <a:solidFill>
                   <a:srgbClr val="E7F0F5"/>
                 </a:solidFill>
                 <a:latin typeface="Calibri"/>
               </a:rPr>
-              <a:t>•  Temporal slices are capped samples; multiclass temporal coverage incomplete</a:t>
+              <a:t>•  DDoS BLOCK_SOURCE: measured effectiveness 1.00  (sim prior 0.82 · Δ +0.18)</a:t>
             </a:r>
           </a:p>
           <a:p>
             <a:pPr>
               <a:spcAft>
-                <a:spcPts val="800"/>
+                <a:spcPts val="700"/>
               </a:spcAft>
             </a:pPr>
             <a:r>
-              <a:rPr sz="1800" b="0">
+              <a:rPr sz="1600" b="0">
                 <a:solidFill>
                   <a:srgbClr val="E7F0F5"/>
                 </a:solidFill>
                 <a:latin typeface="Calibri"/>
               </a:rPr>
-              <a:t>•  IID drift check ≠ temporal / live / cross-dataset drift</a:t>
+              <a:t>•  DoS RATE_LIMIT: measured effectiveness 0.80  (sim prior 0.78 · Δ +0.02)</a:t>
             </a:r>
           </a:p>
           <a:p>
             <a:pPr>
               <a:spcAft>
-                <a:spcPts val="800"/>
+                <a:spcPts val="700"/>
               </a:spcAft>
             </a:pPr>
             <a:r>
-              <a:rPr sz="1800" b="0">
+              <a:rPr sz="1600" b="0">
                 <a:solidFill>
                   <a:srgbClr val="E7F0F5"/>
                 </a:solidFill>
                 <a:latin typeface="Calibri"/>
               </a:rPr>
-              <a:t>•  External-dataset validation not performed — stated as future work</a:t>
+              <a:t>•  Recommendation-only does not change traffic — detects ≠ mitigates</a:t>
             </a:r>
           </a:p>
           <a:p>
             <a:pPr>
               <a:spcAft>
-                <a:spcPts val="800"/>
+                <a:spcPts val="700"/>
               </a:spcAft>
             </a:pPr>
             <a:r>
-              <a:rPr sz="1800" b="0">
+              <a:rPr sz="1600" b="0">
                 <a:solidFill>
                   <a:srgbClr val="E7F0F5"/>
                 </a:solidFill>
                 <a:latin typeface="Calibri"/>
               </a:rPr>
-              <a:t>•  Not a claim of production IDS readiness</a:t>
+              <a:t>•  CONTROLLED lab only — not production firewall/EDR effectiveness</a:t>
+            </a:r>
+          </a:p>
+        </p:txBody>
+      </p:sp>
+      <p:sp>
+        <p:nvSpPr>
+          <p:cNvPr id="6" name="TextBox 5"/>
+          <p:cNvSpPr txBox="1"/>
+          <p:nvPr/>
+        </p:nvSpPr>
+        <p:spPr>
+          <a:xfrm>
+            <a:off x="640080" y="5623560"/>
+            <a:ext cx="10972800" cy="502920"/>
+          </a:xfrm>
+          <a:prstGeom prst="rect">
+            <a:avLst/>
+          </a:prstGeom>
+          <a:noFill/>
+        </p:spPr>
+        <p:txBody>
+          <a:bodyPr wrap="none">
+            <a:spAutoFit/>
+          </a:bodyPr>
+          <a:lstStyle/>
+          <a:p>
+            <a:r>
+              <a:rPr sz="1400" b="1">
+                <a:solidFill>
+                  <a:srgbClr val="F0B429"/>
+                </a:solidFill>
+                <a:latin typeface="Calibri"/>
+              </a:rPr>
+              <a:t>Keep both numbers: simulation assumptions stay labelled assumptions.</a:t>
+            </a:r>
+          </a:p>
+        </p:txBody>
+      </p:sp>
+      <p:sp>
+        <p:nvSpPr>
+          <p:cNvPr id="7" name="TextBox 6"/>
+          <p:cNvSpPr txBox="1"/>
+          <p:nvPr/>
+        </p:nvSpPr>
+        <p:spPr>
+          <a:xfrm>
+            <a:off x="548640" y="6446520"/>
+            <a:ext cx="11155680" cy="320040"/>
+          </a:xfrm>
+          <a:prstGeom prst="rect">
+            <a:avLst/>
+          </a:prstGeom>
+          <a:noFill/>
+        </p:spPr>
+        <p:txBody>
+          <a:bodyPr wrap="none">
+            <a:spAutoFit/>
+          </a:bodyPr>
+          <a:lstStyle/>
+          <a:p>
+            <a:r>
+              <a:rPr sz="1100" b="0">
+                <a:solidFill>
+                  <a:srgbClr val="8FA6B5"/>
+                </a:solidFill>
+                <a:latin typeface="Calibri"/>
+              </a:rPr>
+              <a:t>Aegis IDS  ·  v2.0-aegis-productionized  ·  Research baseline v1.1-research</a:t>
             </a:r>
           </a:p>
         </p:txBody>
@@ -4330,7 +4641,7 @@
         <p:spPr>
           <a:xfrm>
             <a:off x="548640" y="320040"/>
-            <a:ext cx="10972800" cy="914400"/>
+            <a:ext cx="11155680" cy="914400"/>
           </a:xfrm>
           <a:prstGeom prst="rect">
             <a:avLst/>
@@ -4344,13 +4655,13 @@
           <a:lstStyle/>
           <a:p>
             <a:r>
-              <a:rPr sz="3200" b="1">
+              <a:rPr sz="3000" b="1">
                 <a:solidFill>
                   <a:srgbClr val="3EC7C2"/>
                 </a:solidFill>
                 <a:latin typeface="Calibri"/>
               </a:rPr>
-              <a:t>Contribution</a:t>
+              <a:t>P12 — Final security validation</a:t>
             </a:r>
           </a:p>
         </p:txBody>
@@ -4363,8 +4674,42 @@
         </p:nvSpPr>
         <p:spPr>
           <a:xfrm>
-            <a:off x="640080" y="1645920"/>
-            <a:ext cx="10972800" cy="4754880"/>
+            <a:off x="548640" y="960120"/>
+            <a:ext cx="11155680" cy="457200"/>
+          </a:xfrm>
+          <a:prstGeom prst="rect">
+            <a:avLst/>
+          </a:prstGeom>
+          <a:noFill/>
+        </p:spPr>
+        <p:txBody>
+          <a:bodyPr wrap="none">
+            <a:spAutoFit/>
+          </a:bodyPr>
+          <a:lstStyle/>
+          <a:p>
+            <a:r>
+              <a:rPr sz="1400" b="0">
+                <a:solidFill>
+                  <a:srgbClr val="8FA6B5"/>
+                </a:solidFill>
+                <a:latin typeface="Calibri"/>
+              </a:rPr>
+              <a:t>Overall: PASS</a:t>
+            </a:r>
+          </a:p>
+        </p:txBody>
+      </p:sp>
+      <p:sp>
+        <p:nvSpPr>
+          <p:cNvPr id="5" name="TextBox 4"/>
+          <p:cNvSpPr txBox="1"/>
+          <p:nvPr/>
+        </p:nvSpPr>
+        <p:spPr>
+          <a:xfrm>
+            <a:off x="640080" y="1554480"/>
+            <a:ext cx="10972800" cy="4937760"/>
           </a:xfrm>
           <a:prstGeom prst="rect">
             <a:avLst/>
@@ -4379,63 +4724,79 @@
           <a:p>
             <a:pPr>
               <a:spcAft>
-                <a:spcPts val="800"/>
+                <a:spcPts val="700"/>
               </a:spcAft>
             </a:pPr>
             <a:r>
-              <a:rPr sz="2000" b="0">
+              <a:rPr sz="1700" b="0">
                 <a:solidFill>
                   <a:srgbClr val="E7F0F5"/>
                 </a:solidFill>
                 <a:latin typeface="Calibri"/>
               </a:rPr>
-              <a:t>•  Integrated ML-IDS decision-support + visualization platform</a:t>
+              <a:t>•  Auth/RBAC · Response safety · API/input · Persistence/recovery</a:t>
             </a:r>
           </a:p>
           <a:p>
             <a:pPr>
               <a:spcAft>
-                <a:spcPts val="800"/>
+                <a:spcPts val="700"/>
               </a:spcAft>
             </a:pPr>
             <a:r>
-              <a:rPr sz="2000" b="0">
+              <a:rPr sz="1700" b="0">
                 <a:solidFill>
                   <a:srgbClr val="E7F0F5"/>
                 </a:solidFill>
                 <a:latin typeface="Calibri"/>
               </a:rPr>
-              <a:t>•  Honest evaluation: IID · temporal · drift · residual errors · model selection</a:t>
+              <a:t>•  Model-serving · Simulation isolation · Empirical integrity · Audit</a:t>
             </a:r>
           </a:p>
           <a:p>
             <a:pPr>
               <a:spcAft>
-                <a:spcPts val="800"/>
+                <a:spcPts val="700"/>
               </a:spcAft>
             </a:pPr>
             <a:r>
-              <a:rPr sz="2000" b="0">
+              <a:rPr sz="1700" b="0">
                 <a:solidFill>
                   <a:srgbClr val="E7F0F5"/>
                 </a:solidFill>
                 <a:latin typeface="Calibri"/>
               </a:rPr>
-              <a:t>•  Research baseline frozen; Stage-2 productionization is a separate track</a:t>
-            </a:r>
-          </a:p>
-        </p:txBody>
-      </p:sp>
-      <p:sp>
-        <p:nvSpPr>
-          <p:cNvPr id="5" name="TextBox 4"/>
+              <a:t>•  Production boundary · Frozen research baseline hashes</a:t>
+            </a:r>
+          </a:p>
+          <a:p>
+            <a:pPr>
+              <a:spcAft>
+                <a:spcPts val="700"/>
+              </a:spcAft>
+            </a:pPr>
+            <a:r>
+              <a:rPr sz="1700" b="0">
+                <a:solidFill>
+                  <a:srgbClr val="E7F0F5"/>
+                </a:solidFill>
+                <a:latin typeface="Calibri"/>
+              </a:rPr>
+              <a:t>•  Outcome: productionized security-validated prototype — not enterprise SOC claim</a:t>
+            </a:r>
+          </a:p>
+        </p:txBody>
+      </p:sp>
+      <p:sp>
+        <p:nvSpPr>
+          <p:cNvPr id="6" name="TextBox 5"/>
           <p:cNvSpPr txBox="1"/>
           <p:nvPr/>
         </p:nvSpPr>
         <p:spPr>
           <a:xfrm>
-            <a:off x="640080" y="4754880"/>
-            <a:ext cx="10972800" cy="1371600"/>
+            <a:off x="548640" y="6446520"/>
+            <a:ext cx="11155680" cy="320040"/>
           </a:xfrm>
           <a:prstGeom prst="rect">
             <a:avLst/>
@@ -4449,13 +4810,730 @@
           <a:lstStyle/>
           <a:p>
             <a:r>
+              <a:rPr sz="1100" b="0">
+                <a:solidFill>
+                  <a:srgbClr val="8FA6B5"/>
+                </a:solidFill>
+                <a:latin typeface="Calibri"/>
+              </a:rPr>
+              <a:t>Aegis IDS  ·  v2.0-aegis-productionized  ·  Research baseline v1.1-research</a:t>
+            </a:r>
+          </a:p>
+        </p:txBody>
+      </p:sp>
+    </p:spTree>
+  </p:cSld>
+  <p:clrMapOvr>
+    <a:masterClrMapping/>
+  </p:clrMapOvr>
+</p:sld>
+</file>
+
+<file path=ppt/slides/slide16.xml><?xml version="1.0" encoding="utf-8"?>
+<p:sld xmlns:a="http://schemas.openxmlformats.org/drawingml/2006/main" xmlns:p="http://schemas.openxmlformats.org/presentationml/2006/main" xmlns:r="http://schemas.openxmlformats.org/officeDocument/2006/relationships">
+  <p:cSld>
+    <p:spTree>
+      <p:nvGrpSpPr>
+        <p:cNvPr id="1" name=""/>
+        <p:cNvGrpSpPr/>
+        <p:nvPr/>
+      </p:nvGrpSpPr>
+      <p:grpSpPr/>
+      <p:sp>
+        <p:nvSpPr>
+          <p:cNvPr id="2" name="Rectangle 1"/>
+          <p:cNvSpPr/>
+          <p:nvPr/>
+        </p:nvSpPr>
+        <p:spPr>
+          <a:xfrm>
+            <a:off x="0" y="0"/>
+            <a:ext cx="12191695" cy="6858000"/>
+          </a:xfrm>
+          <a:prstGeom prst="rect">
+            <a:avLst/>
+          </a:prstGeom>
+          <a:solidFill>
+            <a:srgbClr val="07111A"/>
+          </a:solidFill>
+          <a:ln>
+            <a:noFill/>
+          </a:ln>
+        </p:spPr>
+        <p:style>
+          <a:lnRef idx="1">
+            <a:schemeClr val="accent1"/>
+          </a:lnRef>
+          <a:fillRef idx="3">
+            <a:schemeClr val="accent1"/>
+          </a:fillRef>
+          <a:effectRef idx="2">
+            <a:schemeClr val="accent1"/>
+          </a:effectRef>
+          <a:fontRef idx="minor">
+            <a:schemeClr val="lt1"/>
+          </a:fontRef>
+        </p:style>
+        <p:txBody>
+          <a:bodyPr rtlCol="0" anchor="ctr"/>
+          <a:lstStyle/>
+          <a:p>
+            <a:pPr algn="ctr"/>
+          </a:p>
+        </p:txBody>
+      </p:sp>
+      <p:sp>
+        <p:nvSpPr>
+          <p:cNvPr id="3" name="TextBox 2"/>
+          <p:cNvSpPr txBox="1"/>
+          <p:nvPr/>
+        </p:nvSpPr>
+        <p:spPr>
+          <a:xfrm>
+            <a:off x="548640" y="320040"/>
+            <a:ext cx="11155680" cy="914400"/>
+          </a:xfrm>
+          <a:prstGeom prst="rect">
+            <a:avLst/>
+          </a:prstGeom>
+          <a:noFill/>
+        </p:spPr>
+        <p:txBody>
+          <a:bodyPr wrap="none">
+            <a:spAutoFit/>
+          </a:bodyPr>
+          <a:lstStyle/>
+          <a:p>
+            <a:r>
+              <a:rPr sz="3000" b="1">
+                <a:solidFill>
+                  <a:srgbClr val="3EC7C2"/>
+                </a:solidFill>
+                <a:latin typeface="Calibri"/>
+              </a:rPr>
+              <a:t>System demonstration</a:t>
+            </a:r>
+          </a:p>
+        </p:txBody>
+      </p:sp>
+      <p:sp>
+        <p:nvSpPr>
+          <p:cNvPr id="4" name="TextBox 3"/>
+          <p:cNvSpPr txBox="1"/>
+          <p:nvPr/>
+        </p:nvSpPr>
+        <p:spPr>
+          <a:xfrm>
+            <a:off x="548640" y="960120"/>
+            <a:ext cx="11155680" cy="457200"/>
+          </a:xfrm>
+          <a:prstGeom prst="rect">
+            <a:avLst/>
+          </a:prstGeom>
+          <a:noFill/>
+        </p:spPr>
+        <p:txBody>
+          <a:bodyPr wrap="none">
+            <a:spAutoFit/>
+          </a:bodyPr>
+          <a:lstStyle/>
+          <a:p>
+            <a:r>
+              <a:rPr sz="1400" b="0">
+                <a:solidFill>
+                  <a:srgbClr val="8FA6B5"/>
+                </a:solidFill>
+                <a:latin typeface="Calibri"/>
+              </a:rPr>
+              <a:t>See docs/DEMO.md for exact clicks</a:t>
+            </a:r>
+          </a:p>
+        </p:txBody>
+      </p:sp>
+      <p:sp>
+        <p:nvSpPr>
+          <p:cNvPr id="5" name="TextBox 4"/>
+          <p:cNvSpPr txBox="1"/>
+          <p:nvPr/>
+        </p:nvSpPr>
+        <p:spPr>
+          <a:xfrm>
+            <a:off x="640080" y="1554480"/>
+            <a:ext cx="10972800" cy="4937760"/>
+          </a:xfrm>
+          <a:prstGeom prst="rect">
+            <a:avLst/>
+          </a:prstGeom>
+          <a:noFill/>
+        </p:spPr>
+        <p:txBody>
+          <a:bodyPr wrap="square">
+            <a:spAutoFit/>
+          </a:bodyPr>
+          <a:lstStyle/>
+          <a:p>
+            <a:pPr>
+              <a:spcAft>
+                <a:spcPts val="700"/>
+              </a:spcAft>
+            </a:pPr>
+            <a:r>
+              <a:rPr sz="1700" b="0">
+                <a:solidFill>
+                  <a:srgbClr val="E7F0F5"/>
+                </a:solidFill>
+                <a:latin typeface="Calibri"/>
+              </a:rPr>
+              <a:t>•  UI http://127.0.0.1:5173  ·  API http://127.0.0.1:8000/docs</a:t>
+            </a:r>
+          </a:p>
+          <a:p>
+            <a:pPr>
+              <a:spcAft>
+                <a:spcPts val="700"/>
+              </a:spcAft>
+            </a:pPr>
+            <a:r>
+              <a:rPr sz="1700" b="0">
+                <a:solidFill>
+                  <a:srgbClr val="E7F0F5"/>
+                </a:solidFill>
+                <a:latin typeface="Calibri"/>
+              </a:rPr>
+              <a:t>•  Flow: Detection → classification / SHAP → risk → incident</a:t>
+            </a:r>
+          </a:p>
+          <a:p>
+            <a:pPr>
+              <a:spcAft>
+                <a:spcPts val="700"/>
+              </a:spcAft>
+            </a:pPr>
+            <a:r>
+              <a:rPr sz="1700" b="0">
+                <a:solidFill>
+                  <a:srgbClr val="E7F0F5"/>
+                </a:solidFill>
+                <a:latin typeface="Calibri"/>
+              </a:rPr>
+              <a:t>•  Propose → dry-run → approve (CONTROLLED) → verify</a:t>
+            </a:r>
+          </a:p>
+          <a:p>
+            <a:pPr>
+              <a:spcAft>
+                <a:spcPts val="700"/>
+              </a:spcAft>
+            </a:pPr>
+            <a:r>
+              <a:rPr sz="1700" b="0">
+                <a:solidFill>
+                  <a:srgbClr val="E7F0F5"/>
+                </a:solidFill>
+                <a:latin typeface="Calibri"/>
+              </a:rPr>
+              <a:t>•  Simulation lifecycle · System / ops readiness</a:t>
+            </a:r>
+          </a:p>
+        </p:txBody>
+      </p:sp>
+      <p:sp>
+        <p:nvSpPr>
+          <p:cNvPr id="6" name="TextBox 5"/>
+          <p:cNvSpPr txBox="1"/>
+          <p:nvPr/>
+        </p:nvSpPr>
+        <p:spPr>
+          <a:xfrm>
+            <a:off x="548640" y="6446520"/>
+            <a:ext cx="11155680" cy="320040"/>
+          </a:xfrm>
+          <a:prstGeom prst="rect">
+            <a:avLst/>
+          </a:prstGeom>
+          <a:noFill/>
+        </p:spPr>
+        <p:txBody>
+          <a:bodyPr wrap="none">
+            <a:spAutoFit/>
+          </a:bodyPr>
+          <a:lstStyle/>
+          <a:p>
+            <a:r>
+              <a:rPr sz="1100" b="0">
+                <a:solidFill>
+                  <a:srgbClr val="8FA6B5"/>
+                </a:solidFill>
+                <a:latin typeface="Calibri"/>
+              </a:rPr>
+              <a:t>Aegis IDS  ·  v2.0-aegis-productionized  ·  Research baseline v1.1-research</a:t>
+            </a:r>
+          </a:p>
+        </p:txBody>
+      </p:sp>
+    </p:spTree>
+  </p:cSld>
+  <p:clrMapOvr>
+    <a:masterClrMapping/>
+  </p:clrMapOvr>
+</p:sld>
+</file>
+
+<file path=ppt/slides/slide17.xml><?xml version="1.0" encoding="utf-8"?>
+<p:sld xmlns:a="http://schemas.openxmlformats.org/drawingml/2006/main" xmlns:p="http://schemas.openxmlformats.org/presentationml/2006/main" xmlns:r="http://schemas.openxmlformats.org/officeDocument/2006/relationships">
+  <p:cSld>
+    <p:spTree>
+      <p:nvGrpSpPr>
+        <p:cNvPr id="1" name=""/>
+        <p:cNvGrpSpPr/>
+        <p:nvPr/>
+      </p:nvGrpSpPr>
+      <p:grpSpPr/>
+      <p:sp>
+        <p:nvSpPr>
+          <p:cNvPr id="2" name="Rectangle 1"/>
+          <p:cNvSpPr/>
+          <p:nvPr/>
+        </p:nvSpPr>
+        <p:spPr>
+          <a:xfrm>
+            <a:off x="0" y="0"/>
+            <a:ext cx="12191695" cy="6858000"/>
+          </a:xfrm>
+          <a:prstGeom prst="rect">
+            <a:avLst/>
+          </a:prstGeom>
+          <a:solidFill>
+            <a:srgbClr val="07111A"/>
+          </a:solidFill>
+          <a:ln>
+            <a:noFill/>
+          </a:ln>
+        </p:spPr>
+        <p:style>
+          <a:lnRef idx="1">
+            <a:schemeClr val="accent1"/>
+          </a:lnRef>
+          <a:fillRef idx="3">
+            <a:schemeClr val="accent1"/>
+          </a:fillRef>
+          <a:effectRef idx="2">
+            <a:schemeClr val="accent1"/>
+          </a:effectRef>
+          <a:fontRef idx="minor">
+            <a:schemeClr val="lt1"/>
+          </a:fontRef>
+        </p:style>
+        <p:txBody>
+          <a:bodyPr rtlCol="0" anchor="ctr"/>
+          <a:lstStyle/>
+          <a:p>
+            <a:pPr algn="ctr"/>
+          </a:p>
+        </p:txBody>
+      </p:sp>
+      <p:sp>
+        <p:nvSpPr>
+          <p:cNvPr id="3" name="TextBox 2"/>
+          <p:cNvSpPr txBox="1"/>
+          <p:nvPr/>
+        </p:nvSpPr>
+        <p:spPr>
+          <a:xfrm>
+            <a:off x="548640" y="320040"/>
+            <a:ext cx="11155680" cy="914400"/>
+          </a:xfrm>
+          <a:prstGeom prst="rect">
+            <a:avLst/>
+          </a:prstGeom>
+          <a:noFill/>
+        </p:spPr>
+        <p:txBody>
+          <a:bodyPr wrap="none">
+            <a:spAutoFit/>
+          </a:bodyPr>
+          <a:lstStyle/>
+          <a:p>
+            <a:r>
+              <a:rPr sz="3000" b="1">
+                <a:solidFill>
+                  <a:srgbClr val="3EC7C2"/>
+                </a:solidFill>
+                <a:latin typeface="Calibri"/>
+              </a:rPr>
+              <a:t>Limitations &amp; future work</a:t>
+            </a:r>
+          </a:p>
+        </p:txBody>
+      </p:sp>
+      <p:sp>
+        <p:nvSpPr>
+          <p:cNvPr id="4" name="TextBox 3"/>
+          <p:cNvSpPr txBox="1"/>
+          <p:nvPr/>
+        </p:nvSpPr>
+        <p:spPr>
+          <a:xfrm>
+            <a:off x="640080" y="1554480"/>
+            <a:ext cx="10972800" cy="4937760"/>
+          </a:xfrm>
+          <a:prstGeom prst="rect">
+            <a:avLst/>
+          </a:prstGeom>
+          <a:noFill/>
+        </p:spPr>
+        <p:txBody>
+          <a:bodyPr wrap="square">
+            <a:spAutoFit/>
+          </a:bodyPr>
+          <a:lstStyle/>
+          <a:p>
+            <a:pPr>
+              <a:spcAft>
+                <a:spcPts val="700"/>
+              </a:spcAft>
+            </a:pPr>
+            <a:r>
               <a:rPr sz="1600" b="0">
                 <a:solidFill>
+                  <a:srgbClr val="E7F0F5"/>
+                </a:solidFill>
+                <a:latin typeface="Calibri"/>
+              </a:rPr>
+              <a:t>•  CICIDS2017 IID ≠ continuous enterprise traffic · no zero-day claim</a:t>
+            </a:r>
+          </a:p>
+          <a:p>
+            <a:pPr>
+              <a:spcAft>
+                <a:spcPts val="700"/>
+              </a:spcAft>
+            </a:pPr>
+            <a:r>
+              <a:rPr sz="1600" b="0">
+                <a:solidFill>
+                  <a:srgbClr val="E7F0F5"/>
+                </a:solidFill>
+                <a:latin typeface="Calibri"/>
+              </a:rPr>
+              <a:t>•  Temporal multiclass incomplete for some families · external dataset = future work</a:t>
+            </a:r>
+          </a:p>
+          <a:p>
+            <a:pPr>
+              <a:spcAft>
+                <a:spcPts val="700"/>
+              </a:spcAft>
+            </a:pPr>
+            <a:r>
+              <a:rPr sz="1600" b="0">
+                <a:solidFill>
+                  <a:srgbClr val="E7F0F5"/>
+                </a:solidFill>
+                <a:latin typeface="Calibri"/>
+              </a:rPr>
+              <a:t>•  Simulation efficacy = assumptions · P11 = CONTROLLED lab, not live EDR</a:t>
+            </a:r>
+          </a:p>
+          <a:p>
+            <a:pPr>
+              <a:spcAft>
+                <a:spcPts val="700"/>
+              </a:spcAft>
+            </a:pPr>
+            <a:r>
+              <a:rPr sz="1600" b="0">
+                <a:solidFill>
+                  <a:srgbClr val="E7F0F5"/>
+                </a:solidFill>
+                <a:latin typeface="Calibri"/>
+              </a:rPr>
+              <a:t>•  Future: frozen cross-dataset eval · broader temporal families · opt-in sandbox enforcement later</a:t>
+            </a:r>
+          </a:p>
+        </p:txBody>
+      </p:sp>
+      <p:sp>
+        <p:nvSpPr>
+          <p:cNvPr id="5" name="TextBox 4"/>
+          <p:cNvSpPr txBox="1"/>
+          <p:nvPr/>
+        </p:nvSpPr>
+        <p:spPr>
+          <a:xfrm>
+            <a:off x="548640" y="6446520"/>
+            <a:ext cx="11155680" cy="320040"/>
+          </a:xfrm>
+          <a:prstGeom prst="rect">
+            <a:avLst/>
+          </a:prstGeom>
+          <a:noFill/>
+        </p:spPr>
+        <p:txBody>
+          <a:bodyPr wrap="none">
+            <a:spAutoFit/>
+          </a:bodyPr>
+          <a:lstStyle/>
+          <a:p>
+            <a:r>
+              <a:rPr sz="1100" b="0">
+                <a:solidFill>
                   <a:srgbClr val="8FA6B5"/>
                 </a:solidFill>
                 <a:latin typeface="Calibri"/>
               </a:rPr>
-              <a:t>Questions?   ·   docs/DEMO.md   ·   docs/VIVA_QA.md   ·   docs/Aegis_IDS_Project_Report.docx</a:t>
+              <a:t>Aegis IDS  ·  v2.0-aegis-productionized  ·  Research baseline v1.1-research</a:t>
+            </a:r>
+          </a:p>
+        </p:txBody>
+      </p:sp>
+    </p:spTree>
+  </p:cSld>
+  <p:clrMapOvr>
+    <a:masterClrMapping/>
+  </p:clrMapOvr>
+</p:sld>
+</file>
+
+<file path=ppt/slides/slide18.xml><?xml version="1.0" encoding="utf-8"?>
+<p:sld xmlns:a="http://schemas.openxmlformats.org/drawingml/2006/main" xmlns:p="http://schemas.openxmlformats.org/presentationml/2006/main" xmlns:r="http://schemas.openxmlformats.org/officeDocument/2006/relationships">
+  <p:cSld>
+    <p:spTree>
+      <p:nvGrpSpPr>
+        <p:cNvPr id="1" name=""/>
+        <p:cNvGrpSpPr/>
+        <p:nvPr/>
+      </p:nvGrpSpPr>
+      <p:grpSpPr/>
+      <p:sp>
+        <p:nvSpPr>
+          <p:cNvPr id="2" name="Rectangle 1"/>
+          <p:cNvSpPr/>
+          <p:nvPr/>
+        </p:nvSpPr>
+        <p:spPr>
+          <a:xfrm>
+            <a:off x="0" y="0"/>
+            <a:ext cx="12191695" cy="6858000"/>
+          </a:xfrm>
+          <a:prstGeom prst="rect">
+            <a:avLst/>
+          </a:prstGeom>
+          <a:solidFill>
+            <a:srgbClr val="07111A"/>
+          </a:solidFill>
+          <a:ln>
+            <a:noFill/>
+          </a:ln>
+        </p:spPr>
+        <p:style>
+          <a:lnRef idx="1">
+            <a:schemeClr val="accent1"/>
+          </a:lnRef>
+          <a:fillRef idx="3">
+            <a:schemeClr val="accent1"/>
+          </a:fillRef>
+          <a:effectRef idx="2">
+            <a:schemeClr val="accent1"/>
+          </a:effectRef>
+          <a:fontRef idx="minor">
+            <a:schemeClr val="lt1"/>
+          </a:fontRef>
+        </p:style>
+        <p:txBody>
+          <a:bodyPr rtlCol="0" anchor="ctr"/>
+          <a:lstStyle/>
+          <a:p>
+            <a:pPr algn="ctr"/>
+          </a:p>
+        </p:txBody>
+      </p:sp>
+      <p:sp>
+        <p:nvSpPr>
+          <p:cNvPr id="3" name="TextBox 2"/>
+          <p:cNvSpPr txBox="1"/>
+          <p:nvPr/>
+        </p:nvSpPr>
+        <p:spPr>
+          <a:xfrm>
+            <a:off x="548640" y="320040"/>
+            <a:ext cx="11155680" cy="914400"/>
+          </a:xfrm>
+          <a:prstGeom prst="rect">
+            <a:avLst/>
+          </a:prstGeom>
+          <a:noFill/>
+        </p:spPr>
+        <p:txBody>
+          <a:bodyPr wrap="none">
+            <a:spAutoFit/>
+          </a:bodyPr>
+          <a:lstStyle/>
+          <a:p>
+            <a:r>
+              <a:rPr sz="3000" b="1">
+                <a:solidFill>
+                  <a:srgbClr val="3EC7C2"/>
+                </a:solidFill>
+                <a:latin typeface="Calibri"/>
+              </a:rPr>
+              <a:t>Conclusion</a:t>
+            </a:r>
+          </a:p>
+        </p:txBody>
+      </p:sp>
+      <p:sp>
+        <p:nvSpPr>
+          <p:cNvPr id="4" name="TextBox 3"/>
+          <p:cNvSpPr txBox="1"/>
+          <p:nvPr/>
+        </p:nvSpPr>
+        <p:spPr>
+          <a:xfrm>
+            <a:off x="640080" y="1600200"/>
+            <a:ext cx="10972800" cy="4937760"/>
+          </a:xfrm>
+          <a:prstGeom prst="rect">
+            <a:avLst/>
+          </a:prstGeom>
+          <a:noFill/>
+        </p:spPr>
+        <p:txBody>
+          <a:bodyPr wrap="square">
+            <a:spAutoFit/>
+          </a:bodyPr>
+          <a:lstStyle/>
+          <a:p>
+            <a:pPr>
+              <a:spcAft>
+                <a:spcPts val="700"/>
+              </a:spcAft>
+            </a:pPr>
+            <a:r>
+              <a:rPr sz="1700" b="0">
+                <a:solidFill>
+                  <a:srgbClr val="E7F0F5"/>
+                </a:solidFill>
+                <a:latin typeface="Calibri"/>
+              </a:rPr>
+              <a:t>•  Aegis IDS: productionized, security-validated IDS prototype</a:t>
+            </a:r>
+          </a:p>
+          <a:p>
+            <a:pPr>
+              <a:spcAft>
+                <a:spcPts val="700"/>
+              </a:spcAft>
+            </a:pPr>
+            <a:r>
+              <a:rPr sz="1700" b="0">
+                <a:solidFill>
+                  <a:srgbClr val="E7F0F5"/>
+                </a:solidFill>
+                <a:latin typeface="Calibri"/>
+              </a:rPr>
+              <a:t>•  Frozen ML + XAI + risk + controlled response + simulation + P11/P12 evidence</a:t>
+            </a:r>
+          </a:p>
+          <a:p>
+            <a:pPr>
+              <a:spcAft>
+                <a:spcPts val="700"/>
+              </a:spcAft>
+            </a:pPr>
+            <a:r>
+              <a:rPr sz="1700" b="0">
+                <a:solidFill>
+                  <a:srgbClr val="E7F0F5"/>
+                </a:solidFill>
+                <a:latin typeface="Calibri"/>
+              </a:rPr>
+              <a:t>•  Hard boundary against live network enforcement preserved</a:t>
+            </a:r>
+          </a:p>
+          <a:p>
+            <a:pPr>
+              <a:spcAft>
+                <a:spcPts val="700"/>
+              </a:spcAft>
+            </a:pPr>
+            <a:r>
+              <a:rPr sz="1700" b="0">
+                <a:solidFill>
+                  <a:srgbClr val="E7F0F5"/>
+                </a:solidFill>
+                <a:latin typeface="Calibri"/>
+              </a:rPr>
+              <a:t>•  Questions?  docs/VIVA_QA.md  ·  docs/PROJECT_REPORT.md  ·  DEMO.md</a:t>
+            </a:r>
+          </a:p>
+        </p:txBody>
+      </p:sp>
+      <p:sp>
+        <p:nvSpPr>
+          <p:cNvPr id="5" name="TextBox 4"/>
+          <p:cNvSpPr txBox="1"/>
+          <p:nvPr/>
+        </p:nvSpPr>
+        <p:spPr>
+          <a:xfrm>
+            <a:off x="640080" y="5029200"/>
+            <a:ext cx="10972800" cy="1097280"/>
+          </a:xfrm>
+          <a:prstGeom prst="rect">
+            <a:avLst/>
+          </a:prstGeom>
+          <a:noFill/>
+        </p:spPr>
+        <p:txBody>
+          <a:bodyPr wrap="square">
+            <a:spAutoFit/>
+          </a:bodyPr>
+          <a:lstStyle/>
+          <a:p>
+            <a:r>
+              <a:rPr sz="1600" b="0">
+                <a:solidFill>
+                  <a:srgbClr val="8FA6B5"/>
+                </a:solidFill>
+                <a:latin typeface="Calibri"/>
+              </a:rPr>
+              <a:t>Thank you
+v1.1-research  ·  v2.0-aegis-productionized  ·  P12 Overall PASS</a:t>
+            </a:r>
+          </a:p>
+        </p:txBody>
+      </p:sp>
+      <p:sp>
+        <p:nvSpPr>
+          <p:cNvPr id="6" name="TextBox 5"/>
+          <p:cNvSpPr txBox="1"/>
+          <p:nvPr/>
+        </p:nvSpPr>
+        <p:spPr>
+          <a:xfrm>
+            <a:off x="548640" y="6446520"/>
+            <a:ext cx="11155680" cy="320040"/>
+          </a:xfrm>
+          <a:prstGeom prst="rect">
+            <a:avLst/>
+          </a:prstGeom>
+          <a:noFill/>
+        </p:spPr>
+        <p:txBody>
+          <a:bodyPr wrap="none">
+            <a:spAutoFit/>
+          </a:bodyPr>
+          <a:lstStyle/>
+          <a:p>
+            <a:r>
+              <a:rPr sz="1100" b="0">
+                <a:solidFill>
+                  <a:srgbClr val="8FA6B5"/>
+                </a:solidFill>
+                <a:latin typeface="Calibri"/>
+              </a:rPr>
+              <a:t>Fill Team / College / Year on slide 1 before the viva</a:t>
             </a:r>
           </a:p>
         </p:txBody>
@@ -4530,7 +5608,7 @@
         <p:spPr>
           <a:xfrm>
             <a:off x="548640" y="320040"/>
-            <a:ext cx="10972800" cy="914400"/>
+            <a:ext cx="11155680" cy="914400"/>
           </a:xfrm>
           <a:prstGeom prst="rect">
             <a:avLst/>
@@ -4544,7 +5622,7 @@
           <a:lstStyle/>
           <a:p>
             <a:r>
-              <a:rPr sz="3200" b="1">
+              <a:rPr sz="3000" b="1">
                 <a:solidFill>
                   <a:srgbClr val="3EC7C2"/>
                 </a:solidFill>
@@ -4563,8 +5641,8 @@
         </p:nvSpPr>
         <p:spPr>
           <a:xfrm>
-            <a:off x="548640" y="1005840"/>
-            <a:ext cx="10972800" cy="502920"/>
+            <a:off x="548640" y="960120"/>
+            <a:ext cx="11155680" cy="457200"/>
           </a:xfrm>
           <a:prstGeom prst="rect">
             <a:avLst/>
@@ -4578,7 +5656,7 @@
           <a:lstStyle/>
           <a:p>
             <a:r>
-              <a:rPr sz="1500" b="0">
+              <a:rPr sz="1400" b="0">
                 <a:solidFill>
                   <a:srgbClr val="8FA6B5"/>
                 </a:solidFill>
@@ -4597,8 +5675,8 @@
         </p:nvSpPr>
         <p:spPr>
           <a:xfrm>
-            <a:off x="640080" y="1691640"/>
-            <a:ext cx="10972800" cy="4754880"/>
+            <a:off x="640080" y="1554480"/>
+            <a:ext cx="10972800" cy="4937760"/>
           </a:xfrm>
           <a:prstGeom prst="rect">
             <a:avLst/>
@@ -4613,11 +5691,11 @@
           <a:p>
             <a:pPr>
               <a:spcAft>
-                <a:spcPts val="800"/>
+                <a:spcPts val="700"/>
               </a:spcAft>
             </a:pPr>
             <a:r>
-              <a:rPr sz="2000" b="0">
+              <a:rPr sz="1800" b="0">
                 <a:solidFill>
                   <a:srgbClr val="E7F0F5"/>
                 </a:solidFill>
@@ -4629,11 +5707,11 @@
           <a:p>
             <a:pPr>
               <a:spcAft>
-                <a:spcPts val="800"/>
+                <a:spcPts val="700"/>
               </a:spcAft>
             </a:pPr>
             <a:r>
-              <a:rPr sz="2000" b="0">
+              <a:rPr sz="1800" b="0">
                 <a:solidFill>
                   <a:srgbClr val="E7F0F5"/>
                 </a:solidFill>
@@ -4645,33 +5723,67 @@
           <a:p>
             <a:pPr>
               <a:spcAft>
-                <a:spcPts val="800"/>
+                <a:spcPts val="700"/>
               </a:spcAft>
             </a:pPr>
             <a:r>
-              <a:rPr sz="2000" b="0">
+              <a:rPr sz="1800" b="0">
                 <a:solidFill>
                   <a:srgbClr val="E7F0F5"/>
                 </a:solidFill>
                 <a:latin typeface="Calibri"/>
               </a:rPr>
-              <a:t>•  Evaluators also need a visual attack → defense story</a:t>
+              <a:t>•  Evaluators need a clear attack → defense story with honest limits</a:t>
             </a:r>
           </a:p>
           <a:p>
             <a:pPr>
               <a:spcAft>
-                <a:spcPts val="800"/>
+                <a:spcPts val="700"/>
               </a:spcAft>
             </a:pPr>
             <a:r>
-              <a:rPr sz="2000" b="0">
+              <a:rPr sz="1800" b="0">
                 <a:solidFill>
                   <a:srgbClr val="E7F0F5"/>
                 </a:solidFill>
                 <a:latin typeface="Calibri"/>
               </a:rPr>
               <a:t>•  Gap: detection alone ≠ security decision support</a:t>
+            </a:r>
+          </a:p>
+        </p:txBody>
+      </p:sp>
+      <p:sp>
+        <p:nvSpPr>
+          <p:cNvPr id="6" name="TextBox 5"/>
+          <p:cNvSpPr txBox="1"/>
+          <p:nvPr/>
+        </p:nvSpPr>
+        <p:spPr>
+          <a:xfrm>
+            <a:off x="548640" y="6446520"/>
+            <a:ext cx="11155680" cy="320040"/>
+          </a:xfrm>
+          <a:prstGeom prst="rect">
+            <a:avLst/>
+          </a:prstGeom>
+          <a:noFill/>
+        </p:spPr>
+        <p:txBody>
+          <a:bodyPr wrap="none">
+            <a:spAutoFit/>
+          </a:bodyPr>
+          <a:lstStyle/>
+          <a:p>
+            <a:r>
+              <a:rPr sz="1100" b="0">
+                <a:solidFill>
+                  <a:srgbClr val="8FA6B5"/>
+                </a:solidFill>
+                <a:latin typeface="Calibri"/>
+              </a:rPr>
+              <a:t>Aegis IDS  ·  v2.0-aegis-productionized  ·  Research baseline v1.1-research</a:t>
             </a:r>
           </a:p>
         </p:txBody>
@@ -4746,7 +5858,7 @@
         <p:spPr>
           <a:xfrm>
             <a:off x="548640" y="320040"/>
-            <a:ext cx="10972800" cy="914400"/>
+            <a:ext cx="11155680" cy="914400"/>
           </a:xfrm>
           <a:prstGeom prst="rect">
             <a:avLst/>
@@ -4760,13 +5872,13 @@
           <a:lstStyle/>
           <a:p>
             <a:r>
-              <a:rPr sz="3200" b="1">
+              <a:rPr sz="3000" b="1">
                 <a:solidFill>
                   <a:srgbClr val="3EC7C2"/>
                 </a:solidFill>
                 <a:latin typeface="Calibri"/>
               </a:rPr>
-              <a:t>Our solution (one pipeline)</a:t>
+              <a:t>Motivation &amp; objectives</a:t>
             </a:r>
           </a:p>
         </p:txBody>
@@ -4779,8 +5891,8 @@
         </p:nvSpPr>
         <p:spPr>
           <a:xfrm>
-            <a:off x="640080" y="1691640"/>
-            <a:ext cx="10972800" cy="4754880"/>
+            <a:off x="640080" y="1554480"/>
+            <a:ext cx="10972800" cy="4937760"/>
           </a:xfrm>
           <a:prstGeom prst="rect">
             <a:avLst/>
@@ -4795,65 +5907,115 @@
           <a:p>
             <a:pPr>
               <a:spcAft>
-                <a:spcPts val="800"/>
+                <a:spcPts val="700"/>
               </a:spcAft>
             </a:pPr>
             <a:r>
-              <a:rPr sz="2200" b="0">
+              <a:rPr sz="1700" b="0">
                 <a:solidFill>
                   <a:srgbClr val="E7F0F5"/>
                 </a:solidFill>
                 <a:latin typeface="Calibri"/>
               </a:rPr>
-              <a:t>•  Detect → Classify → Explain → Assess risk → Recommend → Simulate</a:t>
+              <a:t>•  Bridge detection → explainable decision support with human control</a:t>
             </a:r>
           </a:p>
           <a:p>
             <a:pPr>
               <a:spcAft>
-                <a:spcPts val="800"/>
+                <a:spcPts val="700"/>
               </a:spcAft>
             </a:pPr>
             <a:r>
-              <a:rPr sz="2200" b="0">
+              <a:rPr sz="1700" b="0">
                 <a:solidFill>
                   <a:srgbClr val="E7F0F5"/>
                 </a:solidFill>
                 <a:latin typeface="Calibri"/>
               </a:rPr>
-              <a:t>•  Platform: Aegis IDS (prototype / decision-support)</a:t>
+              <a:t>•  Detect &amp; classify CICIDS2017 flows with a frozen research baseline</a:t>
             </a:r>
           </a:p>
           <a:p>
             <a:pPr>
               <a:spcAft>
-                <a:spcPts val="800"/>
+                <a:spcPts val="700"/>
               </a:spcAft>
             </a:pPr>
             <a:r>
-              <a:rPr sz="2200" b="0">
+              <a:rPr sz="1700" b="0">
                 <a:solidFill>
                   <a:srgbClr val="E7F0F5"/>
                 </a:solidFill>
                 <a:latin typeface="Calibri"/>
               </a:rPr>
-              <a:t>•  Contribution: integration + honest evaluation — not a new IDS algorithm claim</a:t>
+              <a:t>•  Explain (SHAP), score risk, recommend advisory defenses</a:t>
             </a:r>
           </a:p>
           <a:p>
             <a:pPr>
               <a:spcAft>
-                <a:spcPts val="800"/>
+                <a:spcPts val="700"/>
               </a:spcAft>
             </a:pPr>
             <a:r>
-              <a:rPr sz="2200" b="0">
+              <a:rPr sz="1700" b="0">
                 <a:solidFill>
                   <a:srgbClr val="E7F0F5"/>
                 </a:solidFill>
                 <a:latin typeface="Calibri"/>
               </a:rPr>
-              <a:t>•  Safety: no live capture claim · no automatic network blocking</a:t>
+              <a:t>•  Simulate the lifecycle; apply CONTROLLED responses with approval</a:t>
+            </a:r>
+          </a:p>
+          <a:p>
+            <a:pPr>
+              <a:spcAft>
+                <a:spcPts val="700"/>
+              </a:spcAft>
+            </a:pPr>
+            <a:r>
+              <a:rPr sz="1700" b="0">
+                <a:solidFill>
+                  <a:srgbClr val="E7F0F5"/>
+                </a:solidFill>
+                <a:latin typeface="Calibri"/>
+              </a:rPr>
+              <a:t>•  Productionize safely (P0–P12) without inflating research metrics</a:t>
+            </a:r>
+          </a:p>
+        </p:txBody>
+      </p:sp>
+      <p:sp>
+        <p:nvSpPr>
+          <p:cNvPr id="5" name="TextBox 4"/>
+          <p:cNvSpPr txBox="1"/>
+          <p:nvPr/>
+        </p:nvSpPr>
+        <p:spPr>
+          <a:xfrm>
+            <a:off x="548640" y="6446520"/>
+            <a:ext cx="11155680" cy="320040"/>
+          </a:xfrm>
+          <a:prstGeom prst="rect">
+            <a:avLst/>
+          </a:prstGeom>
+          <a:noFill/>
+        </p:spPr>
+        <p:txBody>
+          <a:bodyPr wrap="none">
+            <a:spAutoFit/>
+          </a:bodyPr>
+          <a:lstStyle/>
+          <a:p>
+            <a:r>
+              <a:rPr sz="1100" b="0">
+                <a:solidFill>
+                  <a:srgbClr val="8FA6B5"/>
+                </a:solidFill>
+                <a:latin typeface="Calibri"/>
+              </a:rPr>
+              <a:t>Aegis IDS  ·  v2.0-aegis-productionized  ·  Research baseline v1.1-research</a:t>
             </a:r>
           </a:p>
         </p:txBody>
@@ -4928,7 +6090,7 @@
         <p:spPr>
           <a:xfrm>
             <a:off x="548640" y="320040"/>
-            <a:ext cx="10972800" cy="914400"/>
+            <a:ext cx="11155680" cy="914400"/>
           </a:xfrm>
           <a:prstGeom prst="rect">
             <a:avLst/>
@@ -4942,13 +6104,13 @@
           <a:lstStyle/>
           <a:p>
             <a:r>
-              <a:rPr sz="3200" b="1">
+              <a:rPr sz="3000" b="1">
                 <a:solidFill>
                   <a:srgbClr val="3EC7C2"/>
                 </a:solidFill>
                 <a:latin typeface="Calibri"/>
               </a:rPr>
-              <a:t>Architecture</a:t>
+              <a:t>Limitations of many existing demos / systems</a:t>
             </a:r>
           </a:p>
         </p:txBody>
@@ -4961,8 +6123,8 @@
         </p:nvSpPr>
         <p:spPr>
           <a:xfrm>
-            <a:off x="640080" y="1691640"/>
-            <a:ext cx="10972800" cy="4754880"/>
+            <a:off x="640080" y="1554480"/>
+            <a:ext cx="10972800" cy="4937760"/>
           </a:xfrm>
           <a:prstGeom prst="rect">
             <a:avLst/>
@@ -4977,65 +6139,115 @@
           <a:p>
             <a:pPr>
               <a:spcAft>
-                <a:spcPts val="800"/>
+                <a:spcPts val="700"/>
               </a:spcAft>
             </a:pPr>
             <a:r>
-              <a:rPr sz="2000" b="0">
+              <a:rPr sz="1700" b="0">
                 <a:solidFill>
                   <a:srgbClr val="E7F0F5"/>
                 </a:solidFill>
                 <a:latin typeface="Calibri"/>
               </a:rPr>
-              <a:t>•  React UI  ↔  FastAPI  ↔  ML + Risk + Recommendations + Simulation</a:t>
+              <a:t>•  High CICIDS accuracy without temporal / drift honesty</a:t>
             </a:r>
           </a:p>
           <a:p>
             <a:pPr>
               <a:spcAft>
-                <a:spcPts val="800"/>
+                <a:spcPts val="700"/>
               </a:spcAft>
             </a:pPr>
             <a:r>
-              <a:rPr sz="2000" b="0">
+              <a:rPr sz="1700" b="0">
                 <a:solidFill>
                   <a:srgbClr val="E7F0F5"/>
                 </a:solidFill>
                 <a:latin typeface="Calibri"/>
               </a:rPr>
-              <a:t>•  Data: CICIDS2017 MachineLearningCVE · trained models · SQLite incidents</a:t>
+              <a:t>•  Opaque models → weak analyst trust</a:t>
             </a:r>
           </a:p>
           <a:p>
             <a:pPr>
               <a:spcAft>
-                <a:spcPts val="800"/>
+                <a:spcPts val="700"/>
               </a:spcAft>
             </a:pPr>
             <a:r>
-              <a:rPr sz="2000" b="0">
+              <a:rPr sz="1700" b="0">
                 <a:solidFill>
                   <a:srgbClr val="E7F0F5"/>
                 </a:solidFill>
                 <a:latin typeface="Calibri"/>
               </a:rPr>
-              <a:t>•  Two-stage ML: binary then attack-family multiclass (no BENIGN in Stage-2)</a:t>
+              <a:t>•  Recommendations missing or auto-enforcement without safeguards</a:t>
             </a:r>
           </a:p>
           <a:p>
             <a:pPr>
               <a:spcAft>
-                <a:spcPts val="800"/>
+                <a:spcPts val="700"/>
               </a:spcAft>
             </a:pPr>
             <a:r>
-              <a:rPr sz="2000" b="0">
+              <a:rPr sz="1700" b="0">
                 <a:solidFill>
                   <a:srgbClr val="E7F0F5"/>
                 </a:solidFill>
                 <a:latin typeface="Calibri"/>
               </a:rPr>
-              <a:t>•  XAI: SHAP (primary) + LIME (secondary)</a:t>
+              <a:t>•  Simulation efficacy confused with measured mitigation</a:t>
+            </a:r>
+          </a:p>
+          <a:p>
+            <a:pPr>
+              <a:spcAft>
+                <a:spcPts val="700"/>
+              </a:spcAft>
+            </a:pPr>
+            <a:r>
+              <a:rPr sz="1700" b="0">
+                <a:solidFill>
+                  <a:srgbClr val="E7F0F5"/>
+                </a:solidFill>
+                <a:latin typeface="Calibri"/>
+              </a:rPr>
+              <a:t>•  Weak story for auth, audit, persistence, and fail-safe recovery</a:t>
+            </a:r>
+          </a:p>
+        </p:txBody>
+      </p:sp>
+      <p:sp>
+        <p:nvSpPr>
+          <p:cNvPr id="5" name="TextBox 4"/>
+          <p:cNvSpPr txBox="1"/>
+          <p:nvPr/>
+        </p:nvSpPr>
+        <p:spPr>
+          <a:xfrm>
+            <a:off x="548640" y="6446520"/>
+            <a:ext cx="11155680" cy="320040"/>
+          </a:xfrm>
+          <a:prstGeom prst="rect">
+            <a:avLst/>
+          </a:prstGeom>
+          <a:noFill/>
+        </p:spPr>
+        <p:txBody>
+          <a:bodyPr wrap="none">
+            <a:spAutoFit/>
+          </a:bodyPr>
+          <a:lstStyle/>
+          <a:p>
+            <a:r>
+              <a:rPr sz="1100" b="0">
+                <a:solidFill>
+                  <a:srgbClr val="8FA6B5"/>
+                </a:solidFill>
+                <a:latin typeface="Calibri"/>
+              </a:rPr>
+              <a:t>Aegis IDS  ·  v2.0-aegis-productionized  ·  Research baseline v1.1-research</a:t>
             </a:r>
           </a:p>
         </p:txBody>
@@ -5110,7 +6322,7 @@
         <p:spPr>
           <a:xfrm>
             <a:off x="548640" y="320040"/>
-            <a:ext cx="10972800" cy="914400"/>
+            <a:ext cx="11155680" cy="914400"/>
           </a:xfrm>
           <a:prstGeom prst="rect">
             <a:avLst/>
@@ -5124,13 +6336,13 @@
           <a:lstStyle/>
           <a:p>
             <a:r>
-              <a:rPr sz="3200" b="1">
+              <a:rPr sz="3000" b="1">
                 <a:solidFill>
                   <a:srgbClr val="3EC7C2"/>
                 </a:solidFill>
                 <a:latin typeface="Calibri"/>
               </a:rPr>
-              <a:t>Dataset &amp; preprocessing</a:t>
+              <a:t>Proposed: Aegis IDS</a:t>
             </a:r>
           </a:p>
         </p:txBody>
@@ -5143,8 +6355,8 @@
         </p:nvSpPr>
         <p:spPr>
           <a:xfrm>
-            <a:off x="548640" y="1005840"/>
-            <a:ext cx="10972800" cy="502920"/>
+            <a:off x="548640" y="960120"/>
+            <a:ext cx="11155680" cy="457200"/>
           </a:xfrm>
           <a:prstGeom prst="rect">
             <a:avLst/>
@@ -5158,13 +6370,13 @@
           <a:lstStyle/>
           <a:p>
             <a:r>
-              <a:rPr sz="1500" b="0">
+              <a:rPr sz="1400" b="0">
                 <a:solidFill>
                   <a:srgbClr val="8FA6B5"/>
                 </a:solidFill>
                 <a:latin typeface="Calibri"/>
               </a:rPr>
-              <a:t>CICIDS2017 MachineLearningCVE</a:t>
+              <a:t>One coherent pipeline</a:t>
             </a:r>
           </a:p>
         </p:txBody>
@@ -5177,8 +6389,8 @@
         </p:nvSpPr>
         <p:spPr>
           <a:xfrm>
-            <a:off x="640080" y="1691640"/>
-            <a:ext cx="10972800" cy="4754880"/>
+            <a:off x="640080" y="1554480"/>
+            <a:ext cx="10972800" cy="4937760"/>
           </a:xfrm>
           <a:prstGeom prst="rect">
             <a:avLst/>
@@ -5193,65 +6405,99 @@
           <a:p>
             <a:pPr>
               <a:spcAft>
-                <a:spcPts val="800"/>
+                <a:spcPts val="700"/>
               </a:spcAft>
             </a:pPr>
             <a:r>
-              <a:rPr sz="2000" b="0">
+              <a:rPr sz="1700" b="0">
                 <a:solidFill>
                   <a:srgbClr val="E7F0F5"/>
                 </a:solidFill>
                 <a:latin typeface="Calibri"/>
               </a:rPr>
-              <a:t>•  Clean · normalize labels · drop rare classes (&lt;50 samples)</a:t>
+              <a:t>•  Detect → Classify → Explain → Risk → Recommend → Approve → CONTROLLED response → Simulate</a:t>
             </a:r>
           </a:p>
           <a:p>
             <a:pPr>
               <a:spcAft>
-                <a:spcPts val="800"/>
+                <a:spcPts val="700"/>
               </a:spcAft>
             </a:pPr>
             <a:r>
-              <a:rPr sz="2000" b="0">
+              <a:rPr sz="1700" b="0">
                 <a:solidFill>
                   <a:srgbClr val="E7F0F5"/>
                 </a:solidFill>
                 <a:latin typeface="Calibri"/>
               </a:rPr>
-              <a:t>•  ~2.52M flows after cleaning; stratified train/val/test</a:t>
+              <a:t>•  Contribution: integration + honest evaluation — not a new IDS algorithm claim</a:t>
             </a:r>
           </a:p>
           <a:p>
             <a:pPr>
               <a:spcAft>
-                <a:spcPts val="800"/>
+                <a:spcPts val="700"/>
               </a:spcAft>
             </a:pPr>
             <a:r>
-              <a:rPr sz="2000" b="0">
+              <a:rPr sz="1700" b="0">
                 <a:solidFill>
                   <a:srgbClr val="E7F0F5"/>
                 </a:solidFill>
                 <a:latin typeface="Calibri"/>
               </a:rPr>
-              <a:t>•  StandardScaler + SelectKBest(f_classif, k=40) fit on train only</a:t>
+              <a:t>•  Hard boundary: no live firewall/EDR · no unapproved automatic response</a:t>
             </a:r>
           </a:p>
           <a:p>
             <a:pPr>
               <a:spcAft>
-                <a:spcPts val="800"/>
+                <a:spcPts val="700"/>
               </a:spcAft>
             </a:pPr>
             <a:r>
-              <a:rPr sz="2000" b="0">
+              <a:rPr sz="1700" b="0">
                 <a:solidFill>
                   <a:srgbClr val="E7F0F5"/>
                 </a:solidFill>
                 <a:latin typeface="Calibri"/>
               </a:rPr>
-              <a:t>•  Attack families: Bot · BruteForce · DDoS · DoS · PortScan · WebAttack</a:t>
+              <a:t>•  Tags: v1.1-research (freeze) · v2.0-aegis-productionized (prototype)</a:t>
+            </a:r>
+          </a:p>
+        </p:txBody>
+      </p:sp>
+      <p:sp>
+        <p:nvSpPr>
+          <p:cNvPr id="6" name="TextBox 5"/>
+          <p:cNvSpPr txBox="1"/>
+          <p:nvPr/>
+        </p:nvSpPr>
+        <p:spPr>
+          <a:xfrm>
+            <a:off x="548640" y="6446520"/>
+            <a:ext cx="11155680" cy="320040"/>
+          </a:xfrm>
+          <a:prstGeom prst="rect">
+            <a:avLst/>
+          </a:prstGeom>
+          <a:noFill/>
+        </p:spPr>
+        <p:txBody>
+          <a:bodyPr wrap="none">
+            <a:spAutoFit/>
+          </a:bodyPr>
+          <a:lstStyle/>
+          <a:p>
+            <a:r>
+              <a:rPr sz="1100" b="0">
+                <a:solidFill>
+                  <a:srgbClr val="8FA6B5"/>
+                </a:solidFill>
+                <a:latin typeface="Calibri"/>
+              </a:rPr>
+              <a:t>Aegis IDS  ·  v2.0-aegis-productionized  ·  Research baseline v1.1-research</a:t>
             </a:r>
           </a:p>
         </p:txBody>
@@ -5326,7 +6572,7 @@
         <p:spPr>
           <a:xfrm>
             <a:off x="548640" y="320040"/>
-            <a:ext cx="10972800" cy="914400"/>
+            <a:ext cx="11155680" cy="914400"/>
           </a:xfrm>
           <a:prstGeom prst="rect">
             <a:avLst/>
@@ -5340,13 +6586,13 @@
           <a:lstStyle/>
           <a:p>
             <a:r>
-              <a:rPr sz="3200" b="1">
+              <a:rPr sz="3000" b="1">
                 <a:solidFill>
                   <a:srgbClr val="3EC7C2"/>
                 </a:solidFill>
                 <a:latin typeface="Calibri"/>
               </a:rPr>
-              <a:t>Two-stage ML results (RQ1)</a:t>
+              <a:t>Architecture</a:t>
             </a:r>
           </a:p>
         </p:txBody>
@@ -5359,8 +6605,119 @@
         </p:nvSpPr>
         <p:spPr>
           <a:xfrm>
-            <a:off x="548640" y="1005840"/>
-            <a:ext cx="10972800" cy="502920"/>
+            <a:off x="548640" y="1554480"/>
+            <a:ext cx="6400800" cy="4937760"/>
+          </a:xfrm>
+          <a:prstGeom prst="rect">
+            <a:avLst/>
+          </a:prstGeom>
+          <a:noFill/>
+        </p:spPr>
+        <p:txBody>
+          <a:bodyPr wrap="square">
+            <a:spAutoFit/>
+          </a:bodyPr>
+          <a:lstStyle/>
+          <a:p>
+            <a:pPr>
+              <a:spcAft>
+                <a:spcPts val="700"/>
+              </a:spcAft>
+            </a:pPr>
+            <a:r>
+              <a:rPr sz="1600" b="0">
+                <a:solidFill>
+                  <a:srgbClr val="E7F0F5"/>
+                </a:solidFill>
+                <a:latin typeface="Calibri"/>
+              </a:rPr>
+              <a:t>•  React SOC UI  ↔  FastAPI  ↔  ML + Risk + XAI + Response + Simulation</a:t>
+            </a:r>
+          </a:p>
+          <a:p>
+            <a:pPr>
+              <a:spcAft>
+                <a:spcPts val="700"/>
+              </a:spcAft>
+            </a:pPr>
+            <a:r>
+              <a:rPr sz="1600" b="0">
+                <a:solidFill>
+                  <a:srgbClr val="E7F0F5"/>
+                </a:solidFill>
+                <a:latin typeface="Calibri"/>
+              </a:rPr>
+              <a:t>•  Adapters: DRY_RUN | CONTROLLED (TestNetworkAdapter) | LIVE (forbidden)</a:t>
+            </a:r>
+          </a:p>
+          <a:p>
+            <a:pPr>
+              <a:spcAft>
+                <a:spcPts val="700"/>
+              </a:spcAft>
+            </a:pPr>
+            <a:r>
+              <a:rPr sz="1600" b="0">
+                <a:solidFill>
+                  <a:srgbClr val="E7F0F5"/>
+                </a:solidFill>
+                <a:latin typeface="Calibri"/>
+              </a:rPr>
+              <a:t>•  Persistence: SQLite incidents / actions / append-only audit</a:t>
+            </a:r>
+          </a:p>
+          <a:p>
+            <a:pPr>
+              <a:spcAft>
+                <a:spcPts val="700"/>
+              </a:spcAft>
+            </a:pPr>
+            <a:r>
+              <a:rPr sz="1600" b="0">
+                <a:solidFill>
+                  <a:srgbClr val="E7F0F5"/>
+                </a:solidFill>
+                <a:latin typeface="Calibri"/>
+              </a:rPr>
+              <a:t>•  Observability: /api/ready · ops metrics · System page</a:t>
+            </a:r>
+          </a:p>
+        </p:txBody>
+      </p:sp>
+      <p:pic>
+        <p:nvPicPr>
+          <p:cNvPr id="5" name="Picture 4" descr="architecture.png"/>
+          <p:cNvPicPr>
+            <a:picLocks noChangeAspect="1"/>
+          </p:cNvPicPr>
+          <p:nvPr/>
+        </p:nvPicPr>
+        <p:blipFill>
+          <a:blip r:embed="rId2"/>
+          <a:stretch>
+            <a:fillRect/>
+          </a:stretch>
+        </p:blipFill>
+        <p:spPr>
+          <a:xfrm>
+            <a:off x="6858000" y="1554480"/>
+            <a:ext cx="4846320" cy="2204028"/>
+          </a:xfrm>
+          <a:prstGeom prst="rect">
+            <a:avLst/>
+          </a:prstGeom>
+        </p:spPr>
+      </p:pic>
+      <p:sp>
+        <p:nvSpPr>
+          <p:cNvPr id="6" name="TextBox 5"/>
+          <p:cNvSpPr txBox="1"/>
+          <p:nvPr/>
+        </p:nvSpPr>
+        <p:spPr>
+          <a:xfrm>
+            <a:off x="548640" y="6446520"/>
+            <a:ext cx="11155680" cy="320040"/>
           </a:xfrm>
           <a:prstGeom prst="rect">
             <a:avLst/>
@@ -5374,100 +6731,13 @@
           <a:lstStyle/>
           <a:p>
             <a:r>
-              <a:rPr sz="1500" b="0">
+              <a:rPr sz="1100" b="0">
                 <a:solidFill>
                   <a:srgbClr val="8FA6B5"/>
                 </a:solidFill>
                 <a:latin typeface="Calibri"/>
               </a:rPr>
-              <a:t>Binary: Decision Tree @ 0.85  ·  Multiclass: Random Forest</a:t>
-            </a:r>
-          </a:p>
-        </p:txBody>
-      </p:sp>
-      <p:sp>
-        <p:nvSpPr>
-          <p:cNvPr id="5" name="TextBox 4"/>
-          <p:cNvSpPr txBox="1"/>
-          <p:nvPr/>
-        </p:nvSpPr>
-        <p:spPr>
-          <a:xfrm>
-            <a:off x="640080" y="1691640"/>
-            <a:ext cx="10972800" cy="4754880"/>
-          </a:xfrm>
-          <a:prstGeom prst="rect">
-            <a:avLst/>
-          </a:prstGeom>
-          <a:noFill/>
-        </p:spPr>
-        <p:txBody>
-          <a:bodyPr wrap="square">
-            <a:spAutoFit/>
-          </a:bodyPr>
-          <a:lstStyle/>
-          <a:p>
-            <a:pPr>
-              <a:spcAft>
-                <a:spcPts val="800"/>
-              </a:spcAft>
-            </a:pPr>
-            <a:r>
-              <a:rPr sz="1900" b="0">
-                <a:solidFill>
-                  <a:srgbClr val="E7F0F5"/>
-                </a:solidFill>
-                <a:latin typeface="Calibri"/>
-              </a:rPr>
-              <a:t>•  Binary test: F1 0.99048 · Recall 0.997 · ROC-AUC 0.99916 · FPR 0.00329</a:t>
-            </a:r>
-          </a:p>
-          <a:p>
-            <a:pPr>
-              <a:spcAft>
-                <a:spcPts val="800"/>
-              </a:spcAft>
-            </a:pPr>
-            <a:r>
-              <a:rPr sz="1900" b="0">
-                <a:solidFill>
-                  <a:srgbClr val="E7F0F5"/>
-                </a:solidFill>
-                <a:latin typeface="Calibri"/>
-              </a:rPr>
-              <a:t>•  Multiclass test: macro-F1 0.99813 · weighted-F1 0.99979 · accuracy 0.99979</a:t>
-            </a:r>
-          </a:p>
-          <a:p>
-            <a:pPr>
-              <a:spcAft>
-                <a:spcPts val="800"/>
-              </a:spcAft>
-            </a:pPr>
-            <a:r>
-              <a:rPr sz="1900" b="0">
-                <a:solidFill>
-                  <a:srgbClr val="E7F0F5"/>
-                </a:solidFill>
-                <a:latin typeface="Calibri"/>
-              </a:rPr>
-              <a:t>•  Candidates compared: LR, Decision Tree, Random Forest, XGBoost</a:t>
-            </a:r>
-          </a:p>
-          <a:p>
-            <a:pPr>
-              <a:spcAft>
-                <a:spcPts val="800"/>
-              </a:spcAft>
-            </a:pPr>
-            <a:r>
-              <a:rPr sz="1900" b="0">
-                <a:solidFill>
-                  <a:srgbClr val="E7F0F5"/>
-                </a:solidFill>
-                <a:latin typeface="Calibri"/>
-              </a:rPr>
-              <a:t>•  IID benchmark strength ≠ live-deployment performance guarantee</a:t>
+              <a:t>Aegis IDS  ·  v2.0-aegis-productionized  ·  Research baseline v1.1-research</a:t>
             </a:r>
           </a:p>
         </p:txBody>
@@ -5542,7 +6812,7 @@
         <p:spPr>
           <a:xfrm>
             <a:off x="548640" y="320040"/>
-            <a:ext cx="10972800" cy="914400"/>
+            <a:ext cx="11155680" cy="914400"/>
           </a:xfrm>
           <a:prstGeom prst="rect">
             <a:avLst/>
@@ -5556,13 +6826,13 @@
           <a:lstStyle/>
           <a:p>
             <a:r>
-              <a:rPr sz="3200" b="1">
+              <a:rPr sz="3000" b="1">
                 <a:solidFill>
                   <a:srgbClr val="3EC7C2"/>
                 </a:solidFill>
                 <a:latin typeface="Calibri"/>
               </a:rPr>
-              <a:t>Why Decision Tree (not XGBoost)?</a:t>
+              <a:t>Dataset &amp; preprocessing</a:t>
             </a:r>
           </a:p>
         </p:txBody>
@@ -5575,8 +6845,8 @@
         </p:nvSpPr>
         <p:spPr>
           <a:xfrm>
-            <a:off x="548640" y="1005840"/>
-            <a:ext cx="10972800" cy="502920"/>
+            <a:off x="548640" y="960120"/>
+            <a:ext cx="11155680" cy="457200"/>
           </a:xfrm>
           <a:prstGeom prst="rect">
             <a:avLst/>
@@ -5590,13 +6860,13 @@
           <a:lstStyle/>
           <a:p>
             <a:r>
-              <a:rPr sz="1500" b="0">
+              <a:rPr sz="1400" b="0">
                 <a:solidFill>
                   <a:srgbClr val="8FA6B5"/>
                 </a:solidFill>
                 <a:latin typeface="Calibri"/>
               </a:rPr>
-              <a:t>Multi-objective selection — recall first</a:t>
+              <a:t>CICIDS2017 MachineLearningCVE</a:t>
             </a:r>
           </a:p>
         </p:txBody>
@@ -5609,8 +6879,8 @@
         </p:nvSpPr>
         <p:spPr>
           <a:xfrm>
-            <a:off x="548640" y="1691640"/>
-            <a:ext cx="5943600" cy="4754880"/>
+            <a:off x="640080" y="1554480"/>
+            <a:ext cx="10972800" cy="4937760"/>
           </a:xfrm>
           <a:prstGeom prst="rect">
             <a:avLst/>
@@ -5625,93 +6895,119 @@
           <a:p>
             <a:pPr>
               <a:spcAft>
-                <a:spcPts val="800"/>
+                <a:spcPts val="700"/>
               </a:spcAft>
             </a:pPr>
             <a:r>
-              <a:rPr sz="1800" b="0">
+              <a:rPr sz="1600" b="0">
                 <a:solidFill>
                   <a:srgbClr val="E7F0F5"/>
                 </a:solidFill>
                 <a:latin typeface="Calibri"/>
               </a:rPr>
-              <a:t>•  Weights: recall 0.30 · F1 0.25 · PR-AUC 0.20 · FPR 0.15 · latency 0.10</a:t>
+              <a:t>•  Clean · normalize labels · drop rare classes (&lt;50 samples)</a:t>
             </a:r>
           </a:p>
           <a:p>
             <a:pPr>
               <a:spcAft>
-                <a:spcPts val="800"/>
+                <a:spcPts val="700"/>
               </a:spcAft>
             </a:pPr>
             <a:r>
-              <a:rPr sz="1800" b="0">
+              <a:rPr sz="1600" b="0">
                 <a:solidFill>
                   <a:srgbClr val="E7F0F5"/>
                 </a:solidFill>
                 <a:latin typeface="Calibri"/>
               </a:rPr>
-              <a:t>•  XGBoost can win raw F1; Decision Tree wins attack recall → selected</a:t>
+              <a:t>•  ~2.52M flows after cleaning; stratified 70% / 10% / 20%</a:t>
             </a:r>
           </a:p>
           <a:p>
             <a:pPr>
               <a:spcAft>
-                <a:spcPts val="800"/>
+                <a:spcPts val="700"/>
               </a:spcAft>
             </a:pPr>
             <a:r>
-              <a:rPr sz="1800" b="0">
+              <a:rPr sz="1600" b="0">
                 <a:solidFill>
                   <a:srgbClr val="E7F0F5"/>
                 </a:solidFill>
                 <a:latin typeface="Calibri"/>
               </a:rPr>
-              <a:t>•  Multiclass: Random Forest edges XGBoost on macro/weighted blend</a:t>
+              <a:t>•  Splits: 1,764,525 / 252,075 / 504,151 · random_state=42</a:t>
             </a:r>
           </a:p>
           <a:p>
             <a:pPr>
               <a:spcAft>
-                <a:spcPts val="800"/>
+                <a:spcPts val="700"/>
               </a:spcAft>
             </a:pPr>
             <a:r>
-              <a:rPr sz="1800" b="0">
+              <a:rPr sz="1600" b="0">
                 <a:solidFill>
                   <a:srgbClr val="E7F0F5"/>
                 </a:solidFill>
                 <a:latin typeface="Calibri"/>
               </a:rPr>
-              <a:t>•  For IDS, missed attacks (FN) are costly — policy matters</a:t>
-            </a:r>
-          </a:p>
-        </p:txBody>
-      </p:sp>
-      <p:pic>
-        <p:nvPicPr>
-          <p:cNvPr id="6" name="Picture 5" descr="model_binary_f1_vs_recall.png"/>
-          <p:cNvPicPr>
-            <a:picLocks noChangeAspect="1"/>
-          </p:cNvPicPr>
-          <p:nvPr/>
-        </p:nvPicPr>
-        <p:blipFill>
-          <a:blip r:embed="rId2"/>
-          <a:stretch>
-            <a:fillRect/>
-          </a:stretch>
-        </p:blipFill>
-        <p:spPr>
-          <a:xfrm>
-            <a:off x="6583680" y="1737360"/>
-            <a:ext cx="5120640" cy="3413760"/>
-          </a:xfrm>
-          <a:prstGeom prst="rect">
-            <a:avLst/>
-          </a:prstGeom>
-        </p:spPr>
-      </p:pic>
+              <a:t>•  StandardScaler + SelectKBest(f_classif, k=40) · dual selectors · train-only fit</a:t>
+            </a:r>
+          </a:p>
+          <a:p>
+            <a:pPr>
+              <a:spcAft>
+                <a:spcPts val="700"/>
+              </a:spcAft>
+            </a:pPr>
+            <a:r>
+              <a:rPr sz="1600" b="0">
+                <a:solidFill>
+                  <a:srgbClr val="E7F0F5"/>
+                </a:solidFill>
+                <a:latin typeface="Calibri"/>
+              </a:rPr>
+              <a:t>•  Families: Bot · BruteForce · DDoS · DoS · PortScan · WebAttack</a:t>
+            </a:r>
+          </a:p>
+        </p:txBody>
+      </p:sp>
+      <p:sp>
+        <p:nvSpPr>
+          <p:cNvPr id="6" name="TextBox 5"/>
+          <p:cNvSpPr txBox="1"/>
+          <p:nvPr/>
+        </p:nvSpPr>
+        <p:spPr>
+          <a:xfrm>
+            <a:off x="548640" y="6446520"/>
+            <a:ext cx="11155680" cy="320040"/>
+          </a:xfrm>
+          <a:prstGeom prst="rect">
+            <a:avLst/>
+          </a:prstGeom>
+          <a:noFill/>
+        </p:spPr>
+        <p:txBody>
+          <a:bodyPr wrap="none">
+            <a:spAutoFit/>
+          </a:bodyPr>
+          <a:lstStyle/>
+          <a:p>
+            <a:r>
+              <a:rPr sz="1100" b="0">
+                <a:solidFill>
+                  <a:srgbClr val="8FA6B5"/>
+                </a:solidFill>
+                <a:latin typeface="Calibri"/>
+              </a:rPr>
+              <a:t>Aegis IDS  ·  v2.0-aegis-productionized  ·  Research baseline v1.1-research</a:t>
+            </a:r>
+          </a:p>
+        </p:txBody>
+      </p:sp>
     </p:spTree>
   </p:cSld>
   <p:clrMapOvr>
@@ -5782,7 +7078,7 @@
         <p:spPr>
           <a:xfrm>
             <a:off x="548640" y="320040"/>
-            <a:ext cx="10972800" cy="914400"/>
+            <a:ext cx="11155680" cy="914400"/>
           </a:xfrm>
           <a:prstGeom prst="rect">
             <a:avLst/>
@@ -5796,13 +7092,13 @@
           <a:lstStyle/>
           <a:p>
             <a:r>
-              <a:rPr sz="3200" b="1">
+              <a:rPr sz="3000" b="1">
                 <a:solidFill>
                   <a:srgbClr val="3EC7C2"/>
                 </a:solidFill>
                 <a:latin typeface="Calibri"/>
               </a:rPr>
-              <a:t>Evaluation figures</a:t>
+              <a:t>ML architecture (two-stage)</a:t>
             </a:r>
           </a:p>
         </p:txBody>
@@ -5815,8 +7111,95 @@
         </p:nvSpPr>
         <p:spPr>
           <a:xfrm>
-            <a:off x="548640" y="1005840"/>
-            <a:ext cx="10972800" cy="502920"/>
+            <a:off x="640080" y="1554480"/>
+            <a:ext cx="10972800" cy="4937760"/>
+          </a:xfrm>
+          <a:prstGeom prst="rect">
+            <a:avLst/>
+          </a:prstGeom>
+          <a:noFill/>
+        </p:spPr>
+        <p:txBody>
+          <a:bodyPr wrap="square">
+            <a:spAutoFit/>
+          </a:bodyPr>
+          <a:lstStyle/>
+          <a:p>
+            <a:pPr>
+              <a:spcAft>
+                <a:spcPts val="700"/>
+              </a:spcAft>
+            </a:pPr>
+            <a:r>
+              <a:rPr sz="1800" b="0">
+                <a:solidFill>
+                  <a:srgbClr val="E7F0F5"/>
+                </a:solidFill>
+                <a:latin typeface="Calibri"/>
+              </a:rPr>
+              <a:t>•  Stage 1 — Binary: BENIGN vs ATTACK → Decision Tree @ threshold 0.85</a:t>
+            </a:r>
+          </a:p>
+          <a:p>
+            <a:pPr>
+              <a:spcAft>
+                <a:spcPts val="700"/>
+              </a:spcAft>
+            </a:pPr>
+            <a:r>
+              <a:rPr sz="1800" b="0">
+                <a:solidFill>
+                  <a:srgbClr val="E7F0F5"/>
+                </a:solidFill>
+                <a:latin typeface="Calibri"/>
+              </a:rPr>
+              <a:t>•  Stage 2 — Attack-only multiclass → Random Forest (no BENIGN class)</a:t>
+            </a:r>
+          </a:p>
+          <a:p>
+            <a:pPr>
+              <a:spcAft>
+                <a:spcPts val="700"/>
+              </a:spcAft>
+            </a:pPr>
+            <a:r>
+              <a:rPr sz="1800" b="0">
+                <a:solidFill>
+                  <a:srgbClr val="E7F0F5"/>
+                </a:solidFill>
+                <a:latin typeface="Calibri"/>
+              </a:rPr>
+              <a:t>•  Candidates compared: Logistic Regression, DT, RF, XGBoost</a:t>
+            </a:r>
+          </a:p>
+          <a:p>
+            <a:pPr>
+              <a:spcAft>
+                <a:spcPts val="700"/>
+              </a:spcAft>
+            </a:pPr>
+            <a:r>
+              <a:rPr sz="1800" b="0">
+                <a:solidFill>
+                  <a:srgbClr val="E7F0F5"/>
+                </a:solidFill>
+                <a:latin typeface="Calibri"/>
+              </a:rPr>
+              <a:t>•  Same feature pipeline for fair algorithm ablation</a:t>
+            </a:r>
+          </a:p>
+        </p:txBody>
+      </p:sp>
+      <p:sp>
+        <p:nvSpPr>
+          <p:cNvPr id="5" name="TextBox 4"/>
+          <p:cNvSpPr txBox="1"/>
+          <p:nvPr/>
+        </p:nvSpPr>
+        <p:spPr>
+          <a:xfrm>
+            <a:off x="548640" y="6446520"/>
+            <a:ext cx="11155680" cy="320040"/>
           </a:xfrm>
           <a:prstGeom prst="rect">
             <a:avLst/>
@@ -5830,65 +7213,17 @@
           <a:lstStyle/>
           <a:p>
             <a:r>
-              <a:rPr sz="1500" b="0">
+              <a:rPr sz="1100" b="0">
                 <a:solidFill>
                   <a:srgbClr val="8FA6B5"/>
                 </a:solidFill>
                 <a:latin typeface="Calibri"/>
               </a:rPr>
-              <a:t>IID test confusion matrix &amp; ROC</a:t>
-            </a:r>
-          </a:p>
-        </p:txBody>
-      </p:sp>
-      <p:pic>
-        <p:nvPicPr>
-          <p:cNvPr id="5" name="Picture 4" descr="binary_confusion_matrix.png"/>
-          <p:cNvPicPr>
-            <a:picLocks noChangeAspect="1"/>
-          </p:cNvPicPr>
-          <p:nvPr/>
-        </p:nvPicPr>
-        <p:blipFill>
-          <a:blip r:embed="rId2"/>
-          <a:stretch>
-            <a:fillRect/>
-          </a:stretch>
-        </p:blipFill>
-        <p:spPr>
-          <a:xfrm>
-            <a:off x="457200" y="1554480"/>
-            <a:ext cx="5715000" cy="4572000"/>
-          </a:xfrm>
-          <a:prstGeom prst="rect">
-            <a:avLst/>
-          </a:prstGeom>
-        </p:spPr>
-      </p:pic>
-      <p:pic>
-        <p:nvPicPr>
-          <p:cNvPr id="6" name="Picture 5" descr="binary_roc.png"/>
-          <p:cNvPicPr>
-            <a:picLocks noChangeAspect="1"/>
-          </p:cNvPicPr>
-          <p:nvPr/>
-        </p:nvPicPr>
-        <p:blipFill>
-          <a:blip r:embed="rId3"/>
-          <a:stretch>
-            <a:fillRect/>
-          </a:stretch>
-        </p:blipFill>
-        <p:spPr>
-          <a:xfrm>
-            <a:off x="6309360" y="1554480"/>
-            <a:ext cx="5715000" cy="4572000"/>
-          </a:xfrm>
-          <a:prstGeom prst="rect">
-            <a:avLst/>
-          </a:prstGeom>
-        </p:spPr>
-      </p:pic>
+              <a:t>Aegis IDS  ·  v2.0-aegis-productionized  ·  Research baseline v1.1-research</a:t>
+            </a:r>
+          </a:p>
+        </p:txBody>
+      </p:sp>
     </p:spTree>
   </p:cSld>
   <p:clrMapOvr>
@@ -5959,7 +7294,7 @@
         <p:spPr>
           <a:xfrm>
             <a:off x="548640" y="320040"/>
-            <a:ext cx="10972800" cy="914400"/>
+            <a:ext cx="11155680" cy="914400"/>
           </a:xfrm>
           <a:prstGeom prst="rect">
             <a:avLst/>
@@ -5973,13 +7308,13 @@
           <a:lstStyle/>
           <a:p>
             <a:r>
-              <a:rPr sz="3200" b="1">
+              <a:rPr sz="3000" b="1">
                 <a:solidFill>
                   <a:srgbClr val="3EC7C2"/>
                 </a:solidFill>
                 <a:latin typeface="Calibri"/>
               </a:rPr>
-              <a:t>Temporal generalization</a:t>
+              <a:t>Model results (research IID)</a:t>
             </a:r>
           </a:p>
         </p:txBody>
@@ -5992,8 +7327,8 @@
         </p:nvSpPr>
         <p:spPr>
           <a:xfrm>
-            <a:off x="548640" y="1005840"/>
-            <a:ext cx="10972800" cy="502920"/>
+            <a:off x="548640" y="960120"/>
+            <a:ext cx="11155680" cy="457200"/>
           </a:xfrm>
           <a:prstGeom prst="rect">
             <a:avLst/>
@@ -6007,13 +7342,13 @@
           <a:lstStyle/>
           <a:p>
             <a:r>
-              <a:rPr sz="1500" b="0">
+              <a:rPr sz="1400" b="0">
                 <a:solidFill>
                   <a:srgbClr val="8FA6B5"/>
                 </a:solidFill>
                 <a:latin typeface="Calibri"/>
               </a:rPr>
-              <a:t>Frozen models · day-aware Friday holdout · no retrain</a:t>
+              <a:t>Frozen artifacts — not a live-network guarantee</a:t>
             </a:r>
           </a:p>
         </p:txBody>
@@ -6026,8 +7361,8 @@
         </p:nvSpPr>
         <p:spPr>
           <a:xfrm>
-            <a:off x="548640" y="1691640"/>
-            <a:ext cx="6035040" cy="4754880"/>
+            <a:off x="502920" y="1554480"/>
+            <a:ext cx="5852160" cy="4937760"/>
           </a:xfrm>
           <a:prstGeom prst="rect">
             <a:avLst/>
@@ -6042,72 +7377,72 @@
           <a:p>
             <a:pPr>
               <a:spcAft>
-                <a:spcPts val="800"/>
+                <a:spcPts val="700"/>
               </a:spcAft>
             </a:pPr>
             <a:r>
-              <a:rPr sz="1700" b="0">
+              <a:rPr sz="1500" b="0">
                 <a:solidFill>
                   <a:srgbClr val="E7F0F5"/>
                 </a:solidFill>
                 <a:latin typeface="Calibri"/>
               </a:rPr>
-              <a:t>•  Friday sample (n=36k, attack rate ~34%): binary F1 0.9977</a:t>
+              <a:t>•  Binary DT @ 0.85: F1 0.99048 · Recall 0.997 · PR-AUC 0.99744 · ROC-AUC 0.99916</a:t>
             </a:r>
           </a:p>
           <a:p>
             <a:pPr>
               <a:spcAft>
-                <a:spcPts val="800"/>
+                <a:spcPts val="700"/>
               </a:spcAft>
             </a:pPr>
             <a:r>
-              <a:rPr sz="1700" b="0">
+              <a:rPr sz="1500" b="0">
                 <a:solidFill>
                   <a:srgbClr val="E7F0F5"/>
                 </a:solidFill>
                 <a:latin typeface="Calibri"/>
               </a:rPr>
-              <a:t>•  Mon–Thu sample (n=60k, ~7% attacks): binary F1 0.980 — mild drop</a:t>
+              <a:t>•  Binary residuals: FP 1,377 · FN 255 (FPR 0.00329 / FNR 0.00300)</a:t>
             </a:r>
           </a:p>
           <a:p>
             <a:pPr>
               <a:spcAft>
-                <a:spcPts val="800"/>
+                <a:spcPts val="700"/>
               </a:spcAft>
             </a:pPr>
             <a:r>
-              <a:rPr sz="1700" b="0">
+              <a:rPr sz="1500" b="0">
                 <a:solidFill>
                   <a:srgbClr val="E7F0F5"/>
                 </a:solidFill>
                 <a:latin typeface="Calibri"/>
               </a:rPr>
-              <a:t>•  Friday multiclass only Bot/DDoS/PortScan — not a 6-class temporal claim</a:t>
+              <a:t>•  Multiclass RF: macro-F1 0.99813 · weighted-F1 0.99979 · accuracy 0.99979</a:t>
             </a:r>
           </a:p>
           <a:p>
             <a:pPr>
               <a:spcAft>
-                <a:spcPts val="800"/>
+                <a:spcPts val="700"/>
               </a:spcAft>
             </a:pPr>
             <a:r>
-              <a:rPr sz="1700" b="0">
+              <a:rPr sz="1500" b="0">
                 <a:solidFill>
                   <a:srgbClr val="E7F0F5"/>
                 </a:solidFill>
                 <a:latin typeface="Calibri"/>
               </a:rPr>
-              <a:t>•  Message: IID strength ≠ automatic temporal / live generalization</a:t>
+              <a:t>•  Cite as: performance on the stratified IID holdout</a:t>
             </a:r>
           </a:p>
         </p:txBody>
       </p:sp>
       <p:pic>
         <p:nvPicPr>
-          <p:cNvPr id="6" name="Picture 5" descr="temporal_generalization_summary.png"/>
+          <p:cNvPr id="6" name="Picture 5" descr="binary_confusion_matrix.png"/>
           <p:cNvPicPr>
             <a:picLocks noChangeAspect="1"/>
           </p:cNvPicPr>
@@ -6121,14 +7456,72 @@
         </p:blipFill>
         <p:spPr>
           <a:xfrm>
-            <a:off x="6492240" y="1691640"/>
-            <a:ext cx="5212080" cy="2943292"/>
+            <a:off x="6492240" y="1508760"/>
+            <a:ext cx="2914650" cy="2331720"/>
           </a:xfrm>
           <a:prstGeom prst="rect">
             <a:avLst/>
           </a:prstGeom>
         </p:spPr>
       </p:pic>
+      <p:pic>
+        <p:nvPicPr>
+          <p:cNvPr id="7" name="Picture 6" descr="binary_roc.png"/>
+          <p:cNvPicPr>
+            <a:picLocks noChangeAspect="1"/>
+          </p:cNvPicPr>
+          <p:nvPr/>
+        </p:nvPicPr>
+        <p:blipFill>
+          <a:blip r:embed="rId3"/>
+          <a:stretch>
+            <a:fillRect/>
+          </a:stretch>
+        </p:blipFill>
+        <p:spPr>
+          <a:xfrm>
+            <a:off x="6492240" y="3931920"/>
+            <a:ext cx="2743200" cy="2194560"/>
+          </a:xfrm>
+          <a:prstGeom prst="rect">
+            <a:avLst/>
+          </a:prstGeom>
+        </p:spPr>
+      </p:pic>
+      <p:sp>
+        <p:nvSpPr>
+          <p:cNvPr id="8" name="TextBox 7"/>
+          <p:cNvSpPr txBox="1"/>
+          <p:nvPr/>
+        </p:nvSpPr>
+        <p:spPr>
+          <a:xfrm>
+            <a:off x="548640" y="6446520"/>
+            <a:ext cx="11155680" cy="320040"/>
+          </a:xfrm>
+          <a:prstGeom prst="rect">
+            <a:avLst/>
+          </a:prstGeom>
+          <a:noFill/>
+        </p:spPr>
+        <p:txBody>
+          <a:bodyPr wrap="none">
+            <a:spAutoFit/>
+          </a:bodyPr>
+          <a:lstStyle/>
+          <a:p>
+            <a:r>
+              <a:rPr sz="1100" b="0">
+                <a:solidFill>
+                  <a:srgbClr val="8FA6B5"/>
+                </a:solidFill>
+                <a:latin typeface="Calibri"/>
+              </a:rPr>
+              <a:t>Aegis IDS  ·  v2.0-aegis-productionized  ·  Research baseline v1.1-research</a:t>
+            </a:r>
+          </a:p>
+        </p:txBody>
+      </p:sp>
     </p:spTree>
   </p:cSld>
   <p:clrMapOvr>

</xml_diff>